<commit_message>
Deck: H1-focus planned slide + Conservative/Average/Active scenario fan
- Planned slide now leads with the H1-vs-H1 like-for-like (+13%, 9,211 vs 8,162)
  and flags that full-year 2027 looks larger only because 2026 H2 is light; the
  cross-year chart gains an H1|H2 divider, an 'H2 2027 incomplete' marker and a
  footnote so the H1 focus is explicit.
- Scenario slide replaced with the Conservative/Average/Active fan chart (shaded
  range + 2025 actual), bullets quoting the three annual + implied totals and the
  Active-vs-Conservative risk span; points to the renamed Excel Scenario Analysis sheet.

Co-Authored-By: Claude Opus 4.8 <noreply@anthropic.com>
Claude-Session: https://claude.ai/code/session_015p5NLGbwXS8USzMXyom8VW
</commit_message>
<xml_diff>
--- a/output/outage_deck.pptx
+++ b/output/outage_deck.pptx
@@ -11265,7 +11265,7 @@
                 </a:solidFill>
                 <a:latin typeface="Arial"/>
               </a:rPr>
-              <a:t>US planned capacity offline (kbd); only planned is comparable vs 2027</a:t>
+              <a:t>US planned capacity offline (kbd); 2027 book complete through H1 only</a:t>
             </a:r>
           </a:p>
         </p:txBody>
@@ -11364,8 +11364,8 @@
         </p:blipFill>
         <p:spPr>
           <a:xfrm>
-            <a:off x="411480" y="2049314"/>
-            <a:ext cx="6766560" cy="3125132"/>
+            <a:off x="411480" y="1992897"/>
+            <a:ext cx="6766560" cy="3237965"/>
           </a:xfrm>
           <a:prstGeom prst="rect">
             <a:avLst/>
@@ -11489,7 +11489,7 @@
                 </a:solidFill>
                 <a:latin typeface="Arial"/>
               </a:rPr>
-              <a:t>2027 planned ~15,923 kbd: +32% vs 2026 (~12,029) but -18% vs 2025 (~19,417) - a step up from a light 2026.</a:t>
+              <a:t>H1 is the clean read: 2027 H1 planned ~9,211 kbd vs 2026 H1 ~8,162 (+13%) - a real, like-for-like step up.</a:t>
             </a:r>
           </a:p>
         </p:txBody>
@@ -11572,7 +11572,7 @@
                 </a:solidFill>
                 <a:latin typeface="Arial"/>
               </a:rPr>
-              <a:t>Gulf Coast leads the build: PADD 3 planned +73% y/y; PADD 1 +109% and PADD 4 +88% off small bases.</a:t>
+              <a:t>Full-year looks larger (+32% vs 2026) only because 2026 H2 is light/incomplete; don't over-read it - 2027 H2 is still being scheduled.</a:t>
             </a:r>
           </a:p>
         </p:txBody>
@@ -11655,7 +11655,7 @@
                 </a:solidFill>
                 <a:latin typeface="Arial"/>
               </a:rPr>
-              <a:t>PADD 2 is the only region lighter y/y (-14%); PADD 5 roughly flat (+14%).</a:t>
+              <a:t>Gulf Coast leads the build: PADD 3 planned +73% y/y; PADD 2 is the only region lighter (-14%).</a:t>
             </a:r>
           </a:p>
         </p:txBody>
@@ -11822,6 +11822,45 @@
                 <a:latin typeface="Arial"/>
               </a:rPr>
               <a:t>Only planned is comparable vs 2027 (no actual unplanned-2027 exists); the unplanned outlook is next.</a:t>
+            </a:r>
+          </a:p>
+        </p:txBody>
+      </p:sp>
+      <p:sp>
+        <p:nvSpPr>
+          <p:cNvPr id="18" name="TextBox 17"/>
+          <p:cNvSpPr txBox="1"/>
+          <p:nvPr/>
+        </p:nvSpPr>
+        <p:spPr>
+          <a:xfrm>
+            <a:off x="457200" y="6163056"/>
+            <a:ext cx="10515600" cy="219456"/>
+          </a:xfrm>
+          <a:prstGeom prst="rect">
+            <a:avLst/>
+          </a:prstGeom>
+          <a:noFill/>
+        </p:spPr>
+        <p:txBody>
+          <a:bodyPr wrap="square" anchor="t" lIns="12700" rIns="12700" tIns="12700" bIns="12700">
+            <a:spAutoFit/>
+          </a:bodyPr>
+          <a:lstStyle/>
+          <a:p>
+            <a:pPr algn="l">
+              <a:spcAft>
+                <a:spcPts val="300"/>
+              </a:spcAft>
+            </a:pPr>
+            <a:r>
+              <a:rPr sz="800" b="0" i="1">
+                <a:solidFill>
+                  <a:srgbClr val="595959"/>
+                </a:solidFill>
+                <a:latin typeface="Arial"/>
+              </a:rPr>
+              <a:t>2027 planned data is incomplete past H1 - compare H1-vs-H1; the full-year bar fills in as operators book H2.</a:t>
             </a:r>
           </a:p>
         </p:txBody>
@@ -11878,7 +11917,7 @@
                 </a:solidFill>
                 <a:latin typeface="Arial"/>
               </a:rPr>
-              <a:t>2027 Potential Unplanned - Forecast &amp; Scenario</a:t>
+              <a:t>2027 Potential Unplanned - Scenario Fan</a:t>
             </a:r>
           </a:p>
         </p:txBody>
@@ -11917,7 +11956,7 @@
                 </a:solidFill>
                 <a:latin typeface="Arial"/>
               </a:rPr>
-              <a:t>Driver-based forecast built off the historical monthly shape</a:t>
+              <a:t>Conservative / Average / Active paths off the 2022-25 seasonal baseline</a:t>
             </a:r>
           </a:p>
         </p:txBody>
@@ -12002,7 +12041,7 @@
       </p:sp>
       <p:pic>
         <p:nvPicPr>
-          <p:cNvPr id="6" name="Picture 5" descr="scenario.png"/>
+          <p:cNvPr id="6" name="Picture 5" descr="fan.png"/>
           <p:cNvPicPr>
             <a:picLocks noChangeAspect="1"/>
           </p:cNvPicPr>
@@ -12016,8 +12055,8 @@
         </p:blipFill>
         <p:spPr>
           <a:xfrm>
-            <a:off x="411480" y="2083506"/>
-            <a:ext cx="6766560" cy="3056748"/>
+            <a:off x="411480" y="2049314"/>
+            <a:ext cx="6766560" cy="3125132"/>
           </a:xfrm>
           <a:prstGeom prst="rect">
             <a:avLst/>
@@ -12141,7 +12180,7 @@
                 </a:solidFill>
                 <a:latin typeface="Arial"/>
               </a:rPr>
-              <a:t>Baseline scenario (2022-25 window, neutral dials): ~21,790 kbd unplanned on top of 15,923 planned -&gt; ~37,713 kbd implied total.</a:t>
+              <a:t>Average case ~21,790 kbd unplanned; Conservative ~17,432 (calm year, x0.8), Active ~28,327 (heavy year, x1.3).</a:t>
             </a:r>
           </a:p>
         </p:txBody>
@@ -12224,7 +12263,7 @@
                 </a:solidFill>
                 <a:latin typeface="Arial"/>
               </a:rPr>
-              <a:t>Historical range over the window: P25 ~21,001 / P50 ~22,106 / P90 ~23,373 kbd unplanned.</a:t>
+              <a:t>On top of 15,923 kbd booked planned, that's an implied total of ~33,355 / ~37,713 / ~44,250 kbd.</a:t>
             </a:r>
           </a:p>
         </p:txBody>
@@ -12307,7 +12346,7 @@
                 </a:solidFill>
                 <a:latin typeface="Arial"/>
               </a:rPr>
-              <a:t>The unplanned-rate multiplier is the dominant swing; +/-30% moves the forecast by ~+/-6,537 kbd.</a:t>
+              <a:t>Active vs Conservative spans ~10,895 kbd (+63%) - the unplanned risk range to hedge.</a:t>
             </a:r>
           </a:p>
         </p:txBody>
@@ -12473,7 +12512,7 @@
                 </a:solidFill>
                 <a:latin typeface="Arial"/>
               </a:rPr>
-              <a:t>Fully tunable in the Excel Model sheet - window, growth, multiplier, one-off and stress month.</a:t>
+              <a:t>Fully tunable in the Excel Scenario Analysis sheet - window, growth, multiplier, one-off and stress month.</a:t>
             </a:r>
           </a:p>
         </p:txBody>

</xml_diff>

<commit_message>
Model: exclude non-plan Exxon records everywhere; clean the Exxon Gantt
Per request, the records that fail the corporate-plan check (Joliet Sep-Oct
'Crude' duplicate + the 2027 Joliet FCC) are now dropped from the WHOLE model
(build_context cleans df up front), not just the deck's per-unit slice - so the
workbook and dashboard exclude them too, matching the cleaned source dashboard.
The Exxon Gantt no longer shows them (no red-hatched bars); the slide footnote
notes how many records were removed. Workbook QA still passes (23 charts).
</commit_message>
<xml_diff>
--- a/output/outage_deck.pptx
+++ b/output/outage_deck.pptx
@@ -11025,7 +11025,7 @@
                 </a:solidFill>
                 <a:latin typeface="Arial"/>
               </a:rPr>
-              <a:t>Each unit's turnaround as its own bar; red-hatched = no match in Exxon's corporate schedule</a:t>
+              <a:t>Each unit's turnaround as its own bar, reconciled to Exxon's corporate schedule</a:t>
             </a:r>
           </a:p>
         </p:txBody>
@@ -11124,8 +11124,8 @@
         </p:blipFill>
         <p:spPr>
           <a:xfrm>
-            <a:off x="365760" y="1822804"/>
-            <a:ext cx="8138160" cy="3578151"/>
+            <a:off x="365760" y="2226413"/>
+            <a:ext cx="8138160" cy="2770933"/>
           </a:xfrm>
           <a:prstGeom prst="rect">
             <a:avLst/>
@@ -11422,173 +11422,7 @@
       </p:sp>
       <p:sp>
         <p:nvSpPr>
-          <p:cNvPr id="14" name="Rectangle 13"/>
-          <p:cNvSpPr/>
-          <p:nvPr/>
-        </p:nvSpPr>
-        <p:spPr>
-          <a:xfrm>
-            <a:off x="9098280" y="4297680"/>
-            <a:ext cx="82296" cy="82296"/>
-          </a:xfrm>
-          <a:prstGeom prst="rect">
-            <a:avLst/>
-          </a:prstGeom>
-          <a:solidFill>
-            <a:srgbClr val="595959"/>
-          </a:solidFill>
-          <a:ln>
-            <a:noFill/>
-          </a:ln>
-          <a:effectLst/>
-        </p:spPr>
-        <p:style>
-          <a:lnRef idx="1">
-            <a:schemeClr val="accent1"/>
-          </a:lnRef>
-          <a:fillRef idx="3">
-            <a:schemeClr val="accent1"/>
-          </a:fillRef>
-          <a:effectRef idx="2">
-            <a:schemeClr val="accent1"/>
-          </a:effectRef>
-          <a:fontRef idx="minor">
-            <a:schemeClr val="lt1"/>
-          </a:fontRef>
-        </p:style>
-        <p:txBody>
-          <a:bodyPr rtlCol="0" anchor="ctr"/>
-          <a:lstStyle/>
-          <a:p>
-            <a:pPr algn="ctr"/>
-          </a:p>
-        </p:txBody>
-      </p:sp>
-      <p:sp>
-        <p:nvSpPr>
-          <p:cNvPr id="15" name="TextBox 14"/>
-          <p:cNvSpPr txBox="1"/>
-          <p:nvPr/>
-        </p:nvSpPr>
-        <p:spPr>
-          <a:xfrm>
-            <a:off x="9299448" y="4233672"/>
-            <a:ext cx="2679192" cy="566928"/>
-          </a:xfrm>
-          <a:prstGeom prst="rect">
-            <a:avLst/>
-          </a:prstGeom>
-          <a:noFill/>
-        </p:spPr>
-        <p:txBody>
-          <a:bodyPr wrap="square" anchor="t" lIns="12700" rIns="12700" tIns="12700" bIns="12700">
-            <a:spAutoFit/>
-          </a:bodyPr>
-          <a:lstStyle/>
-          <a:p>
-            <a:pPr algn="l">
-              <a:spcAft>
-                <a:spcPts val="300"/>
-              </a:spcAft>
-            </a:pPr>
-            <a:r>
-              <a:rPr sz="950" b="0" i="0">
-                <a:solidFill>
-                  <a:srgbClr val="262B33"/>
-                </a:solidFill>
-                <a:latin typeface="Arial"/>
-              </a:rPr>
-              <a:t>Flagged: Joliet Crude (~230 kbd, Sep-Oct) - not in Exxon's plan.</a:t>
-            </a:r>
-          </a:p>
-        </p:txBody>
-      </p:sp>
-      <p:sp>
-        <p:nvSpPr>
-          <p:cNvPr id="16" name="Rectangle 15"/>
-          <p:cNvSpPr/>
-          <p:nvPr/>
-        </p:nvSpPr>
-        <p:spPr>
-          <a:xfrm>
-            <a:off x="9098280" y="4733544"/>
-            <a:ext cx="82296" cy="82296"/>
-          </a:xfrm>
-          <a:prstGeom prst="rect">
-            <a:avLst/>
-          </a:prstGeom>
-          <a:solidFill>
-            <a:srgbClr val="595959"/>
-          </a:solidFill>
-          <a:ln>
-            <a:noFill/>
-          </a:ln>
-          <a:effectLst/>
-        </p:spPr>
-        <p:style>
-          <a:lnRef idx="1">
-            <a:schemeClr val="accent1"/>
-          </a:lnRef>
-          <a:fillRef idx="3">
-            <a:schemeClr val="accent1"/>
-          </a:fillRef>
-          <a:effectRef idx="2">
-            <a:schemeClr val="accent1"/>
-          </a:effectRef>
-          <a:fontRef idx="minor">
-            <a:schemeClr val="lt1"/>
-          </a:fontRef>
-        </p:style>
-        <p:txBody>
-          <a:bodyPr rtlCol="0" anchor="ctr"/>
-          <a:lstStyle/>
-          <a:p>
-            <a:pPr algn="ctr"/>
-          </a:p>
-        </p:txBody>
-      </p:sp>
-      <p:sp>
-        <p:nvSpPr>
-          <p:cNvPr id="17" name="TextBox 16"/>
-          <p:cNvSpPr txBox="1"/>
-          <p:nvPr/>
-        </p:nvSpPr>
-        <p:spPr>
-          <a:xfrm>
-            <a:off x="9299448" y="4669536"/>
-            <a:ext cx="2679192" cy="566928"/>
-          </a:xfrm>
-          <a:prstGeom prst="rect">
-            <a:avLst/>
-          </a:prstGeom>
-          <a:noFill/>
-        </p:spPr>
-        <p:txBody>
-          <a:bodyPr wrap="square" anchor="t" lIns="12700" rIns="12700" tIns="12700" bIns="12700">
-            <a:spAutoFit/>
-          </a:bodyPr>
-          <a:lstStyle/>
-          <a:p>
-            <a:pPr algn="l">
-              <a:spcAft>
-                <a:spcPts val="300"/>
-              </a:spcAft>
-            </a:pPr>
-            <a:r>
-              <a:rPr sz="950" b="0" i="0">
-                <a:solidFill>
-                  <a:srgbClr val="262B33"/>
-                </a:solidFill>
-                <a:latin typeface="Arial"/>
-              </a:rPr>
-              <a:t>Flagged: Joliet FCCU (~98 kbd, Apr-May) - not in Exxon's plan.</a:t>
-            </a:r>
-          </a:p>
-        </p:txBody>
-      </p:sp>
-      <p:sp>
-        <p:nvSpPr>
-          <p:cNvPr id="18" name="TextBox 17"/>
+          <p:cNvPr id="14" name="TextBox 13"/>
           <p:cNvSpPr txBox="1"/>
           <p:nvPr/>
         </p:nvSpPr>
@@ -11620,7 +11454,7 @@
                 </a:solidFill>
                 <a:latin typeface="Arial"/>
               </a:rPr>
-              <a:t>Cross-checked against ExxonMobil's corporate turnaround plan (data/exxon_ta_plan.csv). Match = same refinery + unit class overlapping the same months.</a:t>
+              <a:t>Reconciled to ExxonMobil's corporate turnaround plan (data/exxon_ta_plan.csv); 2 records not in the plan removed. Match = same refinery + unit class, overlapping months.</a:t>
             </a:r>
           </a:p>
         </p:txBody>
@@ -12047,7 +11881,7 @@
                 </a:solidFill>
                 <a:latin typeface="Arial"/>
               </a:rPr>
-              <a:t>Average ~21,788 kbd unplanned; Conservative ~17,431 (calm year), Active ~28,325 (heavy). Booked planned is ~15,923 kbd.</a:t>
+              <a:t>Average ~21,788 kbd unplanned; Conservative ~17,431 (calm year), Active ~28,325 (heavy). Booked planned is ~15,379 kbd.</a:t>
             </a:r>
           </a:p>
         </p:txBody>
@@ -12130,7 +11964,7 @@
                 </a:solidFill>
                 <a:latin typeface="Arial"/>
               </a:rPr>
-              <a:t>Implied total ~33,354 / ~37,711 / ~44,248 kbd (Conservative / Average / Active).</a:t>
+              <a:t>Implied total ~32,810 / ~37,167 / ~43,704 kbd (Conservative / Average / Active).</a:t>
             </a:r>
           </a:p>
         </p:txBody>

</xml_diff>

<commit_message>
Refresh to fuller verified data; robust 2023-2025 unplanned baseline
Re-vendor the fuller verified book (3,096 events back to 2022/2023 with real
multi-year unplanned + unknown history) so the 2027 unplanned scenario
extrapolates off actual data, not a 2-year stub.

- Baseline window -> 2023-2025 (DEFAULT_WINDOW): 2022 unplanned coverage is
  sparse (~0.9k kbd-months vs ~11-15k for 2023-25), so it's excluded.
- Hard floor: only 2023+ is verified, so the Enhanced loader now drops 2021/2022
  rows entirely (ENHANCED_MIN_YEAR).
- Dedup exact-duplicate events in the loader.

Scenario now: 2023-25 baseline, Average ~13.3k kbd-months unplanned, P25/P50/P90
= 12.3k/13.0k/14.8k. Deck + dashboard rebuilt; workbook QA still passes.
</commit_message>
<xml_diff>
--- a/output/outage_deck.pptx
+++ b/output/outage_deck.pptx
@@ -11881,7 +11881,7 @@
                 </a:solidFill>
                 <a:latin typeface="Arial"/>
               </a:rPr>
-              <a:t>Average ~6,825 kbd unplanned; Conservative ~5,460 (calm year), Active ~8,873 (heavy). Booked planned is ~15,691 kbd.</a:t>
+              <a:t>Average ~13,296 kbd unplanned; Conservative ~10,637 (calm year), Active ~17,285 (heavy). Booked planned is ~15,691 kbd.</a:t>
             </a:r>
           </a:p>
         </p:txBody>
@@ -11964,7 +11964,7 @@
                 </a:solidFill>
                 <a:latin typeface="Arial"/>
               </a:rPr>
-              <a:t>Implied total ~21,151 / ~22,516 / ~24,564 kbd (Conservative / Average / Active).</a:t>
+              <a:t>Implied total ~26,328 / ~28,987 / ~32,976 kbd (Conservative / Average / Active).</a:t>
             </a:r>
           </a:p>
         </p:txBody>

</xml_diff>

<commit_message>
Deck: CDU = atmospheric crude only (stop combining VDU into it)
Per request, the 'Crude / Distillation (CDU+VDU)' focus unit conflated
atmospheric crude with vacuum distillation. Drop VACUUM DISTILLATION from the
CDU focus bucket so CDU is atmospheric crude charge only (label -> 'Crude (CDU)').
VDU is now a non-focus unit: it no longer inflates the CDU panel on the
total-by-unit slide, and the Joliet vacuum bar drops off the Exxon Gantt; the
Exxon bullet now reads 'Joliet crude' not 'crude+vacuum'.
</commit_message>
<xml_diff>
--- a/output/outage_deck.pptx
+++ b/output/outage_deck.pptx
@@ -10092,7 +10092,7 @@
                 </a:solidFill>
                 <a:latin typeface="Arial"/>
               </a:rPr>
-              <a:t>Confirmed 2027 peak: CDU ~1,960, FCC ~654, hydrocracker ~286, reformer ~277 kbd - all in H1.</a:t>
+              <a:t>Confirmed 2027 peak: CDU ~1,607, FCC ~654, hydrocracker ~286, reformer ~277 kbd - all in H1.</a:t>
             </a:r>
           </a:p>
         </p:txBody>
@@ -11124,8 +11124,8 @@
         </p:blipFill>
         <p:spPr>
           <a:xfrm>
-            <a:off x="365760" y="1625735"/>
-            <a:ext cx="8138160" cy="3972289"/>
+            <a:off x="365760" y="1827060"/>
+            <a:ext cx="8138160" cy="3569640"/>
           </a:xfrm>
           <a:prstGeom prst="rect">
             <a:avLst/>
@@ -11390,7 +11390,7 @@
         <p:spPr>
           <a:xfrm>
             <a:off x="8887968" y="3416808"/>
-            <a:ext cx="3090672" cy="804672"/>
+            <a:ext cx="3090672" cy="1042416"/>
           </a:xfrm>
           <a:prstGeom prst="rect">
             <a:avLst/>
@@ -11415,7 +11415,7 @@
                 </a:solidFill>
                 <a:latin typeface="Arial"/>
               </a:rPr>
-              <a:t>Exxon's verified 2027 slate: Baytown &amp; Beaumont FCC in Q1, Joliet crude+vacuum Apr-May, Baton Rouge crude in autumn.</a:t>
+              <a:t>Reconciled to Exxon's own corporate plan (7 units): Baytown &amp; Beaumont FCC in Q1, Joliet crude Apr-May, Baton Rouge crude in autumn.</a:t>
             </a:r>
           </a:p>
         </p:txBody>
@@ -11454,7 +11454,7 @@
                 </a:solidFill>
                 <a:latin typeface="Arial"/>
               </a:rPr>
-              <a:t>Per-unit nameplate offline from the verified outage book.</a:t>
+              <a:t>Cross-checked against ExxonMobil's corporate turnaround plan; match = same refinery + unit class, overlapping months.</a:t>
             </a:r>
           </a:p>
         </p:txBody>

</xml_diff>

<commit_message>
Label chart x-axes (Month / scenario) and y-axes (kbd offline)
Every deck chart now states its axis units: the time-series charts
(2027 confirmed-vs-not, CDU/FCC by PADD, Exxon per-unit gantt, unplanned
fan) carry a 'Month (2027)' x-axis label, and the scenario-total bars get
a '2027 unplanned scenario' x-axis label. Added 'kbd offline' y-labels to
the 2x2 confirmed-vs-not panels, which previously relied on the title
alone. No data or metric change.

Co-Authored-By: Claude Opus 4.8 <noreply@anthropic.com>
Claude-Session: https://claude.ai/code/session_015p5NLGbwXS8USzMXyom8VW
</commit_message>
<xml_diff>
--- a/output/outage_deck.pptx
+++ b/output/outage_deck.pptx
@@ -9884,8 +9884,8 @@
         </p:blipFill>
         <p:spPr>
           <a:xfrm>
-            <a:off x="365760" y="1275566"/>
-            <a:ext cx="8138160" cy="4672628"/>
+            <a:off x="365760" y="1273532"/>
+            <a:ext cx="8138160" cy="4676696"/>
           </a:xfrm>
           <a:prstGeom prst="rect">
             <a:avLst/>
@@ -10492,8 +10492,8 @@
         </p:blipFill>
         <p:spPr>
           <a:xfrm>
-            <a:off x="1649754" y="1234440"/>
-            <a:ext cx="4290011" cy="2331720"/>
+            <a:off x="1652456" y="1234440"/>
+            <a:ext cx="4284608" cy="2331720"/>
           </a:xfrm>
           <a:prstGeom prst="rect">
             <a:avLst/>
@@ -10516,8 +10516,8 @@
         </p:blipFill>
         <p:spPr>
           <a:xfrm>
-            <a:off x="1652694" y="3703320"/>
-            <a:ext cx="4284131" cy="2331720"/>
+            <a:off x="1655392" y="3703320"/>
+            <a:ext cx="4278735" cy="2331720"/>
           </a:xfrm>
           <a:prstGeom prst="rect">
             <a:avLst/>
@@ -11649,8 +11649,8 @@
         </p:blipFill>
         <p:spPr>
           <a:xfrm>
-            <a:off x="1270431" y="1234440"/>
-            <a:ext cx="5048658" cy="2331720"/>
+            <a:off x="1273190" y="1234440"/>
+            <a:ext cx="5043140" cy="2331720"/>
           </a:xfrm>
           <a:prstGeom prst="rect">
             <a:avLst/>
@@ -11673,8 +11673,8 @@
         </p:blipFill>
         <p:spPr>
           <a:xfrm>
-            <a:off x="513079" y="3703320"/>
-            <a:ext cx="6563361" cy="2331720"/>
+            <a:off x="517935" y="3703320"/>
+            <a:ext cx="6553650" cy="2331720"/>
           </a:xfrm>
           <a:prstGeom prst="rect">
             <a:avLst/>

</xml_diff>

<commit_message>
Switch focus-unit charts to day-weighted offline (was full-nameplate peak)
QA confirmed the per-unit metric does not double-count (dedup on plant+unit,
max), does not roll outages forward (each month is independent; a unit only
counts in months its outage actually spans), and never sums across unit
classes. The one thing inflating the headline was the basis: a unit offline
any part of a month was counted at FULL nameplate. Switched unit_offline_monthly,
focus_unit_padd_month and focus_2027_split to day-weighted cap_kbd, so a unit
is credited only for the days it is actually down (= average daily concurrent
offline). CDU Oct-2027 reads ~1,307 kbd vs ~1,907 on the old peak basis. The
per-unit Exxon gantt still labels each bar with its nameplate (correct - one
unit per bar). Deck footnotes now state the day-weighted basis explicitly.

Co-Authored-By: Claude Opus 4.8 <noreply@anthropic.com>
Claude-Session: https://claude.ai/code/session_015p5NLGbwXS8USzMXyom8VW
</commit_message>
<xml_diff>
--- a/output/outage_deck.pptx
+++ b/output/outage_deck.pptx
@@ -10092,7 +10092,7 @@
                 </a:solidFill>
                 <a:latin typeface="Arial"/>
               </a:rPr>
-              <a:t>Confirmed 2027 peak: CDU ~1,607, FCC ~654, hydrocracker ~286, reformer ~277 kbd - all in H1.</a:t>
+              <a:t>Confirmed 2027 peak: CDU ~1,063, FCC ~492, hydrocracker ~219, reformer ~206 kbd - all in H1.</a:t>
             </a:r>
           </a:p>
         </p:txBody>
@@ -10297,7 +10297,7 @@
                 </a:solidFill>
                 <a:latin typeface="Arial"/>
               </a:rPr>
-              <a:t>Concurrent capacity offline, each unit counted once per month. Non-Exxon H2 2027 is a floor that fills in. Verified-bad Exxon records excluded.</a:t>
+              <a:t>Day-weighted concurrent capacity offline (a unit offline part of a month counts only for its days down), each unit once per month. Non-Exxon H2 2027 is a floor that fills in.</a:t>
             </a:r>
           </a:p>
         </p:txBody>
@@ -10929,7 +10929,7 @@
                 </a:solidFill>
                 <a:latin typeface="Arial"/>
               </a:rPr>
-              <a:t>Concurrent capacity offline by month, stacked by PADD. P1 NE, P2 Midwest, P3 Gulf, P4 Rockies, P5 West.</a:t>
+              <a:t>Day-weighted concurrent capacity offline by month, stacked by PADD. P1 NE, P2 Midwest, P3 Gulf, P4 Rockies, P5 West.</a:t>
             </a:r>
           </a:p>
         </p:txBody>

</xml_diff>

<commit_message>
Add 'What's Driving the Numbers' slide - biggest outages by PADD
New slide 3: a horizontal bar of the 12 biggest individual 2027 focus-unit
outages, one bar per physical unit (nameplate kbd), colored by PADD so the
desk sees where the big tonnage sits (PADD 3/Gulf dominates). Refinery + unit
on the axis, size + class + span annotated. Units are never summed - each bar
stands alone. Non-Exxon H2 outages are hatched and tagged as an indicative
floor (not confirmed), consistent with the rest of the deck. Bullets are
data-driven (lead PADD, top-3 names, biggest single outage) so they stay
correct on a refresh. Deck is now 6 slides.

Co-Authored-By: Claude Opus 4.8 <noreply@anthropic.com>
Claude-Session: https://claude.ai/code/session_015p5NLGbwXS8USzMXyom8VW
</commit_message>
<xml_diff>
--- a/output/outage_deck.pptx
+++ b/output/outage_deck.pptx
@@ -10,6 +10,7 @@
     <p:sldId id="258" r:id="rId9"/>
     <p:sldId id="259" r:id="rId10"/>
     <p:sldId id="260" r:id="rId11"/>
+    <p:sldId id="261" r:id="rId12"/>
   </p:sldIdLst>
   <p:sldSz cx="12191695" cy="6858000" type="screen4x3"/>
   <p:notesSz cx="6858000" cy="9144000"/>
@@ -10354,7 +10355,7 @@
                 </a:solidFill>
                 <a:latin typeface="Arial"/>
               </a:rPr>
-              <a:t>Outages by PADD by Unit - Where It Tightens</a:t>
+              <a:t>What's Driving the Numbers - the Biggest Outages</a:t>
             </a:r>
           </a:p>
         </p:txBody>
@@ -10393,7 +10394,7 @@
                 </a:solidFill>
                 <a:latin typeface="Arial"/>
               </a:rPr>
-              <a:t>2027 crude (CDU, top) and cat-cracker (FCC, bottom) offline by region &amp; month</a:t>
+              <a:t>Each bar is one unit's nameplate offline (kbd) in 2027, colored by PADD (region)</a:t>
             </a:r>
           </a:p>
         </p:txBody>
@@ -10478,7 +10479,7 @@
       </p:sp>
       <p:pic>
         <p:nvPicPr>
-          <p:cNvPr id="6" name="Picture 5" descr="cdu_padd_27.png"/>
+          <p:cNvPr id="6" name="Picture 5" descr="biggest_outages.png"/>
           <p:cNvPicPr>
             <a:picLocks noChangeAspect="1"/>
           </p:cNvPicPr>
@@ -10492,48 +10493,24 @@
         </p:blipFill>
         <p:spPr>
           <a:xfrm>
-            <a:off x="1652456" y="1234440"/>
-            <a:ext cx="4284608" cy="2331720"/>
+            <a:off x="910093" y="1188720"/>
+            <a:ext cx="7049493" cy="4846320"/>
           </a:xfrm>
           <a:prstGeom prst="rect">
             <a:avLst/>
           </a:prstGeom>
         </p:spPr>
       </p:pic>
-      <p:pic>
-        <p:nvPicPr>
-          <p:cNvPr id="7" name="Picture 6" descr="fcc_padd_27.png"/>
-          <p:cNvPicPr>
-            <a:picLocks noChangeAspect="1"/>
-          </p:cNvPicPr>
-          <p:nvPr/>
-        </p:nvPicPr>
-        <p:blipFill>
-          <a:blip r:embed="rId3"/>
-          <a:stretch>
-            <a:fillRect/>
-          </a:stretch>
-        </p:blipFill>
-        <p:spPr>
-          <a:xfrm>
-            <a:off x="1655392" y="3703320"/>
-            <a:ext cx="4278735" cy="2331720"/>
-          </a:xfrm>
-          <a:prstGeom prst="rect">
-            <a:avLst/>
-          </a:prstGeom>
-        </p:spPr>
-      </p:pic>
-      <p:sp>
-        <p:nvSpPr>
-          <p:cNvPr id="8" name="TextBox 7"/>
+      <p:sp>
+        <p:nvSpPr>
+          <p:cNvPr id="7" name="TextBox 6"/>
           <p:cNvSpPr txBox="1"/>
           <p:nvPr/>
         </p:nvSpPr>
         <p:spPr>
           <a:xfrm>
-            <a:off x="7452360" y="1371600"/>
-            <a:ext cx="4434840" cy="274320"/>
+            <a:off x="8686800" y="1371600"/>
+            <a:ext cx="3291840" cy="274320"/>
           </a:xfrm>
           <a:prstGeom prst="rect">
             <a:avLst/>
@@ -10552,7 +10529,7 @@
               </a:spcAft>
             </a:pPr>
             <a:r>
-              <a:rPr sz="1350" b="1" i="0">
+              <a:rPr sz="1250" b="1" i="0">
                 <a:solidFill>
                   <a:srgbClr val="1F3864"/>
                 </a:solidFill>
@@ -10565,13 +10542,13 @@
       </p:sp>
       <p:sp>
         <p:nvSpPr>
-          <p:cNvPr id="9" name="Rectangle 8"/>
-          <p:cNvSpPr/>
-          <p:nvPr/>
-        </p:nvSpPr>
-        <p:spPr>
-          <a:xfrm>
-            <a:off x="7452360" y="1847088"/>
+          <p:cNvPr id="8" name="Rectangle 7"/>
+          <p:cNvSpPr/>
+          <p:nvPr/>
+        </p:nvSpPr>
+        <p:spPr>
+          <a:xfrm>
+            <a:off x="8686800" y="1847088"/>
             <a:ext cx="82296" cy="82296"/>
           </a:xfrm>
           <a:prstGeom prst="rect">
@@ -10609,14 +10586,14 @@
       </p:sp>
       <p:sp>
         <p:nvSpPr>
-          <p:cNvPr id="10" name="TextBox 9"/>
+          <p:cNvPr id="9" name="TextBox 8"/>
           <p:cNvSpPr txBox="1"/>
           <p:nvPr/>
         </p:nvSpPr>
         <p:spPr>
           <a:xfrm>
-            <a:off x="7653528" y="1783080"/>
-            <a:ext cx="4233672" cy="804672"/>
+            <a:off x="8887968" y="1783080"/>
+            <a:ext cx="3090672" cy="804672"/>
           </a:xfrm>
           <a:prstGeom prst="rect">
             <a:avLst/>
@@ -10635,26 +10612,26 @@
               </a:spcAft>
             </a:pPr>
             <a:r>
-              <a:rPr sz="1200" b="0" i="0">
+              <a:rPr sz="1100" b="0" i="0">
                 <a:solidFill>
                   <a:srgbClr val="262B33"/>
                 </a:solidFill>
                 <a:latin typeface="Arial"/>
               </a:rPr>
-              <a:t>PADD 3 (Gulf) is the swing region - most crude and FCC work lands there, tightening USGC supply and the export barrel.</a:t>
+              <a:t>The big tonnage sits in PADD 3 - that's where one outage moves USGC supply and the export barrel most.</a:t>
             </a:r>
           </a:p>
         </p:txBody>
       </p:sp>
       <p:sp>
         <p:nvSpPr>
-          <p:cNvPr id="11" name="Rectangle 10"/>
-          <p:cNvSpPr/>
-          <p:nvPr/>
-        </p:nvSpPr>
-        <p:spPr>
-          <a:xfrm>
-            <a:off x="7452360" y="2542032"/>
+          <p:cNvPr id="10" name="Rectangle 9"/>
+          <p:cNvSpPr/>
+          <p:nvPr/>
+        </p:nvSpPr>
+        <p:spPr>
+          <a:xfrm>
+            <a:off x="8686800" y="2496312"/>
             <a:ext cx="82296" cy="82296"/>
           </a:xfrm>
           <a:prstGeom prst="rect">
@@ -10692,14 +10669,14 @@
       </p:sp>
       <p:sp>
         <p:nvSpPr>
-          <p:cNvPr id="12" name="TextBox 11"/>
+          <p:cNvPr id="11" name="TextBox 10"/>
           <p:cNvSpPr txBox="1"/>
           <p:nvPr/>
         </p:nvSpPr>
         <p:spPr>
           <a:xfrm>
-            <a:off x="7653528" y="2478024"/>
-            <a:ext cx="4233672" cy="804672"/>
+            <a:off x="8887968" y="2432304"/>
+            <a:ext cx="3090672" cy="1280160"/>
           </a:xfrm>
           <a:prstGeom prst="rect">
             <a:avLst/>
@@ -10718,26 +10695,26 @@
               </a:spcAft>
             </a:pPr>
             <a:r>
-              <a:rPr sz="1200" b="0" i="0">
+              <a:rPr sz="1100" b="0" i="0">
                 <a:solidFill>
                   <a:srgbClr val="262B33"/>
                 </a:solidFill>
                 <a:latin typeface="Arial"/>
               </a:rPr>
-              <a:t>PADD 2 (Midwest) carries the spring crude (the Joliet event). PADD 5 (West) is islanded - a California outage doesn't get bailed out by other regions.</a:t>
+              <a:t>Biggest single outages: Garyville (275 kbd), Cherry Point (250 kbd), Joliet (250 kbd) - mostly crude (CDU). One crude unit down cuts the whole site's run, every product.</a:t>
             </a:r>
           </a:p>
         </p:txBody>
       </p:sp>
       <p:sp>
         <p:nvSpPr>
-          <p:cNvPr id="13" name="Rectangle 12"/>
-          <p:cNvSpPr/>
-          <p:nvPr/>
-        </p:nvSpPr>
-        <p:spPr>
-          <a:xfrm>
-            <a:off x="7452360" y="3236976"/>
+          <p:cNvPr id="12" name="Rectangle 11"/>
+          <p:cNvSpPr/>
+          <p:nvPr/>
+        </p:nvSpPr>
+        <p:spPr>
+          <a:xfrm>
+            <a:off x="8686800" y="3480816"/>
             <a:ext cx="82296" cy="82296"/>
           </a:xfrm>
           <a:prstGeom prst="rect">
@@ -10775,14 +10752,14 @@
       </p:sp>
       <p:sp>
         <p:nvSpPr>
-          <p:cNvPr id="14" name="TextBox 13"/>
+          <p:cNvPr id="13" name="TextBox 12"/>
           <p:cNvSpPr txBox="1"/>
           <p:nvPr/>
         </p:nvSpPr>
         <p:spPr>
           <a:xfrm>
-            <a:off x="7653528" y="3172968"/>
-            <a:ext cx="4233672" cy="804672"/>
+            <a:off x="8887968" y="3416808"/>
+            <a:ext cx="3090672" cy="804672"/>
           </a:xfrm>
           <a:prstGeom prst="rect">
             <a:avLst/>
@@ -10801,26 +10778,26 @@
               </a:spcAft>
             </a:pPr>
             <a:r>
-              <a:rPr sz="1200" b="0" i="0">
+              <a:rPr sz="1100" b="0" i="0">
                 <a:solidFill>
                   <a:srgbClr val="262B33"/>
                 </a:solidFill>
                 <a:latin typeface="Arial"/>
               </a:rPr>
-              <a:t>Timing: spring (Mar-May) and autumn (Sep-Oct) are the windows; summer is protected for driving-season gasoline.</a:t>
+              <a:t>Read each bar alone - these are individual units, never added. The biggest single outage is ~275 kbd, not a summed total.</a:t>
             </a:r>
           </a:p>
         </p:txBody>
       </p:sp>
       <p:sp>
         <p:nvSpPr>
-          <p:cNvPr id="15" name="Rectangle 14"/>
-          <p:cNvSpPr/>
-          <p:nvPr/>
-        </p:nvSpPr>
-        <p:spPr>
-          <a:xfrm>
-            <a:off x="7452360" y="3931920"/>
+          <p:cNvPr id="14" name="Rectangle 13"/>
+          <p:cNvSpPr/>
+          <p:nvPr/>
+        </p:nvSpPr>
+        <p:spPr>
+          <a:xfrm>
+            <a:off x="8686800" y="4130040"/>
             <a:ext cx="82296" cy="82296"/>
           </a:xfrm>
           <a:prstGeom prst="rect">
@@ -10858,14 +10835,14 @@
       </p:sp>
       <p:sp>
         <p:nvSpPr>
-          <p:cNvPr id="16" name="TextBox 15"/>
+          <p:cNvPr id="15" name="TextBox 14"/>
           <p:cNvSpPr txBox="1"/>
           <p:nvPr/>
         </p:nvSpPr>
         <p:spPr>
           <a:xfrm>
-            <a:off x="7653528" y="3867912"/>
-            <a:ext cx="4233672" cy="804672"/>
+            <a:off x="8887968" y="4066032"/>
+            <a:ext cx="3090672" cy="804672"/>
           </a:xfrm>
           <a:prstGeom prst="rect">
             <a:avLst/>
@@ -10884,20 +10861,20 @@
               </a:spcAft>
             </a:pPr>
             <a:r>
-              <a:rPr sz="1200" b="0" i="0">
+              <a:rPr sz="1100" b="0" i="0">
                 <a:solidFill>
                   <a:srgbClr val="262B33"/>
                 </a:solidFill>
                 <a:latin typeface="Arial"/>
               </a:rPr>
-              <a:t>Past the dotted line (H2) is non-Exxon-unconfirmed - those autumn bars are a floor and grow as operators book.</a:t>
+              <a:t>Hatched bars are non-Exxon H2 - still being booked, so those autumn names are an indicative floor, not confirmed.</a:t>
             </a:r>
           </a:p>
         </p:txBody>
       </p:sp>
       <p:sp>
         <p:nvSpPr>
-          <p:cNvPr id="17" name="TextBox 16"/>
+          <p:cNvPr id="16" name="TextBox 15"/>
           <p:cNvSpPr txBox="1"/>
           <p:nvPr/>
         </p:nvSpPr>
@@ -10929,7 +10906,7 @@
                 </a:solidFill>
                 <a:latin typeface="Arial"/>
               </a:rPr>
-              <a:t>Day-weighted concurrent capacity offline by month, stacked by PADD. P1 NE, P2 Midwest, P3 Gulf, P4 Rockies, P5 West.</a:t>
+              <a:t>Per-unit nameplate offline, the 12 biggest focus-unit outages of 2027. Color = PADD region; hatched = non-Exxon H2 (indicative).</a:t>
             </a:r>
           </a:p>
         </p:txBody>
@@ -10986,7 +10963,7 @@
                 </a:solidFill>
                 <a:latin typeface="Arial"/>
               </a:rPr>
-              <a:t>ExxonMobil 2027 - Per Unit</a:t>
+              <a:t>Outages by PADD by Unit - Where It Tightens</a:t>
             </a:r>
           </a:p>
         </p:txBody>
@@ -11025,7 +11002,7 @@
                 </a:solidFill>
                 <a:latin typeface="Arial"/>
               </a:rPr>
-              <a:t>Each unit's turnaround as its own bar, nameplate capacity offline (kbd)</a:t>
+              <a:t>2027 crude (CDU, top) and cat-cracker (FCC, bottom) offline by region &amp; month</a:t>
             </a:r>
           </a:p>
         </p:txBody>
@@ -11110,7 +11087,7 @@
       </p:sp>
       <p:pic>
         <p:nvPicPr>
-          <p:cNvPr id="6" name="Picture 5" descr="exxon_gantt.png"/>
+          <p:cNvPr id="6" name="Picture 5" descr="cdu_padd_27.png"/>
           <p:cNvPicPr>
             <a:picLocks noChangeAspect="1"/>
           </p:cNvPicPr>
@@ -11124,24 +11101,48 @@
         </p:blipFill>
         <p:spPr>
           <a:xfrm>
-            <a:off x="365760" y="1827060"/>
-            <a:ext cx="8138160" cy="3569640"/>
+            <a:off x="1652456" y="1234440"/>
+            <a:ext cx="4284608" cy="2331720"/>
           </a:xfrm>
           <a:prstGeom prst="rect">
             <a:avLst/>
           </a:prstGeom>
         </p:spPr>
       </p:pic>
-      <p:sp>
-        <p:nvSpPr>
-          <p:cNvPr id="7" name="TextBox 6"/>
+      <p:pic>
+        <p:nvPicPr>
+          <p:cNvPr id="7" name="Picture 6" descr="fcc_padd_27.png"/>
+          <p:cNvPicPr>
+            <a:picLocks noChangeAspect="1"/>
+          </p:cNvPicPr>
+          <p:nvPr/>
+        </p:nvPicPr>
+        <p:blipFill>
+          <a:blip r:embed="rId3"/>
+          <a:stretch>
+            <a:fillRect/>
+          </a:stretch>
+        </p:blipFill>
+        <p:spPr>
+          <a:xfrm>
+            <a:off x="1655392" y="3703320"/>
+            <a:ext cx="4278735" cy="2331720"/>
+          </a:xfrm>
+          <a:prstGeom prst="rect">
+            <a:avLst/>
+          </a:prstGeom>
+        </p:spPr>
+      </p:pic>
+      <p:sp>
+        <p:nvSpPr>
+          <p:cNvPr id="8" name="TextBox 7"/>
           <p:cNvSpPr txBox="1"/>
           <p:nvPr/>
         </p:nvSpPr>
         <p:spPr>
           <a:xfrm>
-            <a:off x="8686800" y="1371600"/>
-            <a:ext cx="3291840" cy="274320"/>
+            <a:off x="7452360" y="1371600"/>
+            <a:ext cx="4434840" cy="274320"/>
           </a:xfrm>
           <a:prstGeom prst="rect">
             <a:avLst/>
@@ -11160,7 +11161,7 @@
               </a:spcAft>
             </a:pPr>
             <a:r>
-              <a:rPr sz="1250" b="1" i="0">
+              <a:rPr sz="1350" b="1" i="0">
                 <a:solidFill>
                   <a:srgbClr val="1F3864"/>
                 </a:solidFill>
@@ -11173,13 +11174,13 @@
       </p:sp>
       <p:sp>
         <p:nvSpPr>
-          <p:cNvPr id="8" name="Rectangle 7"/>
-          <p:cNvSpPr/>
-          <p:nvPr/>
-        </p:nvSpPr>
-        <p:spPr>
-          <a:xfrm>
-            <a:off x="8686800" y="1847088"/>
+          <p:cNvPr id="9" name="Rectangle 8"/>
+          <p:cNvSpPr/>
+          <p:nvPr/>
+        </p:nvSpPr>
+        <p:spPr>
+          <a:xfrm>
+            <a:off x="7452360" y="1847088"/>
             <a:ext cx="82296" cy="82296"/>
           </a:xfrm>
           <a:prstGeom prst="rect">
@@ -11217,14 +11218,14 @@
       </p:sp>
       <p:sp>
         <p:nvSpPr>
-          <p:cNvPr id="9" name="TextBox 8"/>
+          <p:cNvPr id="10" name="TextBox 9"/>
           <p:cNvSpPr txBox="1"/>
           <p:nvPr/>
         </p:nvSpPr>
         <p:spPr>
           <a:xfrm>
-            <a:off x="8887968" y="1783080"/>
-            <a:ext cx="3090672" cy="1042416"/>
+            <a:off x="7653528" y="1783080"/>
+            <a:ext cx="4233672" cy="804672"/>
           </a:xfrm>
           <a:prstGeom prst="rect">
             <a:avLst/>
@@ -11243,26 +11244,26 @@
               </a:spcAft>
             </a:pPr>
             <a:r>
-              <a:rPr sz="1100" b="0" i="0">
+              <a:rPr sz="1200" b="0" i="0">
                 <a:solidFill>
                   <a:srgbClr val="262B33"/>
                 </a:solidFill>
                 <a:latin typeface="Arial"/>
               </a:rPr>
-              <a:t>ExxonMobil is the only operator with a full-year 2027 plan - so it's the one refiner whose H2 we can confirm. Everyone else is H1-only.</a:t>
+              <a:t>PADD 3 (Gulf) is the swing region - most crude and FCC work lands there, tightening USGC supply and the export barrel.</a:t>
             </a:r>
           </a:p>
         </p:txBody>
       </p:sp>
       <p:sp>
         <p:nvSpPr>
-          <p:cNvPr id="10" name="Rectangle 9"/>
-          <p:cNvSpPr/>
-          <p:nvPr/>
-        </p:nvSpPr>
-        <p:spPr>
-          <a:xfrm>
-            <a:off x="8686800" y="2663952"/>
+          <p:cNvPr id="11" name="Rectangle 10"/>
+          <p:cNvSpPr/>
+          <p:nvPr/>
+        </p:nvSpPr>
+        <p:spPr>
+          <a:xfrm>
+            <a:off x="7452360" y="2542032"/>
             <a:ext cx="82296" cy="82296"/>
           </a:xfrm>
           <a:prstGeom prst="rect">
@@ -11300,14 +11301,14 @@
       </p:sp>
       <p:sp>
         <p:nvSpPr>
-          <p:cNvPr id="11" name="TextBox 10"/>
+          <p:cNvPr id="12" name="TextBox 11"/>
           <p:cNvSpPr txBox="1"/>
           <p:nvPr/>
         </p:nvSpPr>
         <p:spPr>
           <a:xfrm>
-            <a:off x="8887968" y="2599944"/>
-            <a:ext cx="3090672" cy="1042416"/>
+            <a:off x="7653528" y="2478024"/>
+            <a:ext cx="4233672" cy="804672"/>
           </a:xfrm>
           <a:prstGeom prst="rect">
             <a:avLst/>
@@ -11326,26 +11327,26 @@
               </a:spcAft>
             </a:pPr>
             <a:r>
-              <a:rPr sz="1100" b="0" i="0">
+              <a:rPr sz="1200" b="0" i="0">
                 <a:solidFill>
                   <a:srgbClr val="262B33"/>
                 </a:solidFill>
                 <a:latin typeface="Arial"/>
               </a:rPr>
-              <a:t>Per unit, never summed - the 'Exxon ~700 kbd' figure was 8 Joliet units in one April turnaround added together; it's really ~250 kbd of crude.</a:t>
+              <a:t>PADD 2 (Midwest) carries the spring crude (the Joliet event). PADD 5 (West) is islanded - a California outage doesn't get bailed out by other regions.</a:t>
             </a:r>
           </a:p>
         </p:txBody>
       </p:sp>
       <p:sp>
         <p:nvSpPr>
-          <p:cNvPr id="12" name="Rectangle 11"/>
-          <p:cNvSpPr/>
-          <p:nvPr/>
-        </p:nvSpPr>
-        <p:spPr>
-          <a:xfrm>
-            <a:off x="8686800" y="3480816"/>
+          <p:cNvPr id="13" name="Rectangle 12"/>
+          <p:cNvSpPr/>
+          <p:nvPr/>
+        </p:nvSpPr>
+        <p:spPr>
+          <a:xfrm>
+            <a:off x="7452360" y="3236976"/>
             <a:ext cx="82296" cy="82296"/>
           </a:xfrm>
           <a:prstGeom prst="rect">
@@ -11383,14 +11384,14 @@
       </p:sp>
       <p:sp>
         <p:nvSpPr>
-          <p:cNvPr id="13" name="TextBox 12"/>
+          <p:cNvPr id="14" name="TextBox 13"/>
           <p:cNvSpPr txBox="1"/>
           <p:nvPr/>
         </p:nvSpPr>
         <p:spPr>
           <a:xfrm>
-            <a:off x="8887968" y="3416808"/>
-            <a:ext cx="3090672" cy="1042416"/>
+            <a:off x="7653528" y="3172968"/>
+            <a:ext cx="4233672" cy="804672"/>
           </a:xfrm>
           <a:prstGeom prst="rect">
             <a:avLst/>
@@ -11409,20 +11410,103 @@
               </a:spcAft>
             </a:pPr>
             <a:r>
-              <a:rPr sz="1100" b="0" i="0">
+              <a:rPr sz="1200" b="0" i="0">
                 <a:solidFill>
                   <a:srgbClr val="262B33"/>
                 </a:solidFill>
                 <a:latin typeface="Arial"/>
               </a:rPr>
-              <a:t>Reconciled to Exxon's own corporate plan (7 units): Baytown &amp; Beaumont FCC in Q1, Joliet crude Apr-May, Baton Rouge crude in autumn.</a:t>
+              <a:t>Timing: spring (Mar-May) and autumn (Sep-Oct) are the windows; summer is protected for driving-season gasoline.</a:t>
             </a:r>
           </a:p>
         </p:txBody>
       </p:sp>
       <p:sp>
         <p:nvSpPr>
-          <p:cNvPr id="14" name="TextBox 13"/>
+          <p:cNvPr id="15" name="Rectangle 14"/>
+          <p:cNvSpPr/>
+          <p:nvPr/>
+        </p:nvSpPr>
+        <p:spPr>
+          <a:xfrm>
+            <a:off x="7452360" y="3931920"/>
+            <a:ext cx="82296" cy="82296"/>
+          </a:xfrm>
+          <a:prstGeom prst="rect">
+            <a:avLst/>
+          </a:prstGeom>
+          <a:solidFill>
+            <a:srgbClr val="BF9000"/>
+          </a:solidFill>
+          <a:ln>
+            <a:noFill/>
+          </a:ln>
+          <a:effectLst/>
+        </p:spPr>
+        <p:style>
+          <a:lnRef idx="1">
+            <a:schemeClr val="accent1"/>
+          </a:lnRef>
+          <a:fillRef idx="3">
+            <a:schemeClr val="accent1"/>
+          </a:fillRef>
+          <a:effectRef idx="2">
+            <a:schemeClr val="accent1"/>
+          </a:effectRef>
+          <a:fontRef idx="minor">
+            <a:schemeClr val="lt1"/>
+          </a:fontRef>
+        </p:style>
+        <p:txBody>
+          <a:bodyPr rtlCol="0" anchor="ctr"/>
+          <a:lstStyle/>
+          <a:p>
+            <a:pPr algn="ctr"/>
+          </a:p>
+        </p:txBody>
+      </p:sp>
+      <p:sp>
+        <p:nvSpPr>
+          <p:cNvPr id="16" name="TextBox 15"/>
+          <p:cNvSpPr txBox="1"/>
+          <p:nvPr/>
+        </p:nvSpPr>
+        <p:spPr>
+          <a:xfrm>
+            <a:off x="7653528" y="3867912"/>
+            <a:ext cx="4233672" cy="804672"/>
+          </a:xfrm>
+          <a:prstGeom prst="rect">
+            <a:avLst/>
+          </a:prstGeom>
+          <a:noFill/>
+        </p:spPr>
+        <p:txBody>
+          <a:bodyPr wrap="square" anchor="t" lIns="12700" rIns="12700" tIns="12700" bIns="12700">
+            <a:spAutoFit/>
+          </a:bodyPr>
+          <a:lstStyle/>
+          <a:p>
+            <a:pPr algn="l">
+              <a:spcAft>
+                <a:spcPts val="300"/>
+              </a:spcAft>
+            </a:pPr>
+            <a:r>
+              <a:rPr sz="1200" b="0" i="0">
+                <a:solidFill>
+                  <a:srgbClr val="262B33"/>
+                </a:solidFill>
+                <a:latin typeface="Arial"/>
+              </a:rPr>
+              <a:t>Past the dotted line (H2) is non-Exxon-unconfirmed - those autumn bars are a floor and grow as operators book.</a:t>
+            </a:r>
+          </a:p>
+        </p:txBody>
+      </p:sp>
+      <p:sp>
+        <p:nvSpPr>
+          <p:cNvPr id="17" name="TextBox 16"/>
           <p:cNvSpPr txBox="1"/>
           <p:nvPr/>
         </p:nvSpPr>
@@ -11454,7 +11538,7 @@
                 </a:solidFill>
                 <a:latin typeface="Arial"/>
               </a:rPr>
-              <a:t>Cross-checked against ExxonMobil's corporate turnaround plan; match = same refinery + unit class, overlapping months.</a:t>
+              <a:t>Day-weighted concurrent capacity offline by month, stacked by PADD. P1 NE, P2 Midwest, P3 Gulf, P4 Rockies, P5 West.</a:t>
             </a:r>
           </a:p>
         </p:txBody>
@@ -11511,6 +11595,531 @@
                 </a:solidFill>
                 <a:latin typeface="Arial"/>
               </a:rPr>
+              <a:t>ExxonMobil 2027 - Per Unit</a:t>
+            </a:r>
+          </a:p>
+        </p:txBody>
+      </p:sp>
+      <p:sp>
+        <p:nvSpPr>
+          <p:cNvPr id="3" name="TextBox 2"/>
+          <p:cNvSpPr txBox="1"/>
+          <p:nvPr/>
+        </p:nvSpPr>
+        <p:spPr>
+          <a:xfrm>
+            <a:off x="457200" y="841248"/>
+            <a:ext cx="11247120" cy="274320"/>
+          </a:xfrm>
+          <a:prstGeom prst="rect">
+            <a:avLst/>
+          </a:prstGeom>
+          <a:noFill/>
+        </p:spPr>
+        <p:txBody>
+          <a:bodyPr wrap="square" anchor="t" lIns="12700" rIns="12700" tIns="12700" bIns="12700">
+            <a:spAutoFit/>
+          </a:bodyPr>
+          <a:lstStyle/>
+          <a:p>
+            <a:pPr algn="l">
+              <a:spcAft>
+                <a:spcPts val="300"/>
+              </a:spcAft>
+            </a:pPr>
+            <a:r>
+              <a:rPr sz="1200" b="0" i="0">
+                <a:solidFill>
+                  <a:srgbClr val="595959"/>
+                </a:solidFill>
+                <a:latin typeface="Arial"/>
+              </a:rPr>
+              <a:t>Each unit's turnaround as its own bar, nameplate capacity offline (kbd)</a:t>
+            </a:r>
+          </a:p>
+        </p:txBody>
+      </p:sp>
+      <p:sp>
+        <p:nvSpPr>
+          <p:cNvPr id="4" name="TextBox 3"/>
+          <p:cNvSpPr txBox="1"/>
+          <p:nvPr/>
+        </p:nvSpPr>
+        <p:spPr>
+          <a:xfrm>
+            <a:off x="411480" y="6382512"/>
+            <a:ext cx="2743200" cy="292608"/>
+          </a:xfrm>
+          <a:prstGeom prst="rect">
+            <a:avLst/>
+          </a:prstGeom>
+          <a:noFill/>
+        </p:spPr>
+        <p:txBody>
+          <a:bodyPr wrap="square" anchor="ctr" lIns="12700" rIns="12700" tIns="12700" bIns="12700">
+            <a:spAutoFit/>
+          </a:bodyPr>
+          <a:lstStyle/>
+          <a:p>
+            <a:pPr algn="l">
+              <a:spcAft>
+                <a:spcPts val="300"/>
+              </a:spcAft>
+            </a:pPr>
+            <a:r>
+              <a:rPr sz="1300" b="1" i="0">
+                <a:solidFill>
+                  <a:srgbClr val="C00000"/>
+                </a:solidFill>
+                <a:latin typeface="Arial"/>
+              </a:rPr>
+              <a:t>Products Trading</a:t>
+            </a:r>
+          </a:p>
+        </p:txBody>
+      </p:sp>
+      <p:sp>
+        <p:nvSpPr>
+          <p:cNvPr id="5" name="TextBox 4"/>
+          <p:cNvSpPr txBox="1"/>
+          <p:nvPr/>
+        </p:nvSpPr>
+        <p:spPr>
+          <a:xfrm>
+            <a:off x="11430000" y="6400800"/>
+            <a:ext cx="640080" cy="274320"/>
+          </a:xfrm>
+          <a:prstGeom prst="rect">
+            <a:avLst/>
+          </a:prstGeom>
+          <a:noFill/>
+        </p:spPr>
+        <p:txBody>
+          <a:bodyPr wrap="square" anchor="t" lIns="12700" rIns="12700" tIns="12700" bIns="12700">
+            <a:spAutoFit/>
+          </a:bodyPr>
+          <a:lstStyle/>
+          <a:p>
+            <a:pPr algn="r">
+              <a:spcAft>
+                <a:spcPts val="300"/>
+              </a:spcAft>
+            </a:pPr>
+            <a:r>
+              <a:rPr sz="900" b="0" i="0">
+                <a:solidFill>
+                  <a:srgbClr val="595959"/>
+                </a:solidFill>
+                <a:latin typeface="Arial"/>
+              </a:rPr>
+              <a:t>4</a:t>
+            </a:r>
+          </a:p>
+        </p:txBody>
+      </p:sp>
+      <p:pic>
+        <p:nvPicPr>
+          <p:cNvPr id="6" name="Picture 5" descr="exxon_gantt.png"/>
+          <p:cNvPicPr>
+            <a:picLocks noChangeAspect="1"/>
+          </p:cNvPicPr>
+          <p:nvPr/>
+        </p:nvPicPr>
+        <p:blipFill>
+          <a:blip r:embed="rId2"/>
+          <a:stretch>
+            <a:fillRect/>
+          </a:stretch>
+        </p:blipFill>
+        <p:spPr>
+          <a:xfrm>
+            <a:off x="365760" y="1827060"/>
+            <a:ext cx="8138160" cy="3569640"/>
+          </a:xfrm>
+          <a:prstGeom prst="rect">
+            <a:avLst/>
+          </a:prstGeom>
+        </p:spPr>
+      </p:pic>
+      <p:sp>
+        <p:nvSpPr>
+          <p:cNvPr id="7" name="TextBox 6"/>
+          <p:cNvSpPr txBox="1"/>
+          <p:nvPr/>
+        </p:nvSpPr>
+        <p:spPr>
+          <a:xfrm>
+            <a:off x="8686800" y="1371600"/>
+            <a:ext cx="3291840" cy="274320"/>
+          </a:xfrm>
+          <a:prstGeom prst="rect">
+            <a:avLst/>
+          </a:prstGeom>
+          <a:noFill/>
+        </p:spPr>
+        <p:txBody>
+          <a:bodyPr wrap="square" anchor="t" lIns="12700" rIns="12700" tIns="12700" bIns="12700">
+            <a:spAutoFit/>
+          </a:bodyPr>
+          <a:lstStyle/>
+          <a:p>
+            <a:pPr algn="l">
+              <a:spcAft>
+                <a:spcPts val="300"/>
+              </a:spcAft>
+            </a:pPr>
+            <a:r>
+              <a:rPr sz="1250" b="1" i="0">
+                <a:solidFill>
+                  <a:srgbClr val="1F3864"/>
+                </a:solidFill>
+                <a:latin typeface="Arial"/>
+              </a:rPr>
+              <a:t>Key takeaways:</a:t>
+            </a:r>
+          </a:p>
+        </p:txBody>
+      </p:sp>
+      <p:sp>
+        <p:nvSpPr>
+          <p:cNvPr id="8" name="Rectangle 7"/>
+          <p:cNvSpPr/>
+          <p:nvPr/>
+        </p:nvSpPr>
+        <p:spPr>
+          <a:xfrm>
+            <a:off x="8686800" y="1847088"/>
+            <a:ext cx="82296" cy="82296"/>
+          </a:xfrm>
+          <a:prstGeom prst="rect">
+            <a:avLst/>
+          </a:prstGeom>
+          <a:solidFill>
+            <a:srgbClr val="BF9000"/>
+          </a:solidFill>
+          <a:ln>
+            <a:noFill/>
+          </a:ln>
+          <a:effectLst/>
+        </p:spPr>
+        <p:style>
+          <a:lnRef idx="1">
+            <a:schemeClr val="accent1"/>
+          </a:lnRef>
+          <a:fillRef idx="3">
+            <a:schemeClr val="accent1"/>
+          </a:fillRef>
+          <a:effectRef idx="2">
+            <a:schemeClr val="accent1"/>
+          </a:effectRef>
+          <a:fontRef idx="minor">
+            <a:schemeClr val="lt1"/>
+          </a:fontRef>
+        </p:style>
+        <p:txBody>
+          <a:bodyPr rtlCol="0" anchor="ctr"/>
+          <a:lstStyle/>
+          <a:p>
+            <a:pPr algn="ctr"/>
+          </a:p>
+        </p:txBody>
+      </p:sp>
+      <p:sp>
+        <p:nvSpPr>
+          <p:cNvPr id="9" name="TextBox 8"/>
+          <p:cNvSpPr txBox="1"/>
+          <p:nvPr/>
+        </p:nvSpPr>
+        <p:spPr>
+          <a:xfrm>
+            <a:off x="8887968" y="1783080"/>
+            <a:ext cx="3090672" cy="1042416"/>
+          </a:xfrm>
+          <a:prstGeom prst="rect">
+            <a:avLst/>
+          </a:prstGeom>
+          <a:noFill/>
+        </p:spPr>
+        <p:txBody>
+          <a:bodyPr wrap="square" anchor="t" lIns="12700" rIns="12700" tIns="12700" bIns="12700">
+            <a:spAutoFit/>
+          </a:bodyPr>
+          <a:lstStyle/>
+          <a:p>
+            <a:pPr algn="l">
+              <a:spcAft>
+                <a:spcPts val="300"/>
+              </a:spcAft>
+            </a:pPr>
+            <a:r>
+              <a:rPr sz="1100" b="0" i="0">
+                <a:solidFill>
+                  <a:srgbClr val="262B33"/>
+                </a:solidFill>
+                <a:latin typeface="Arial"/>
+              </a:rPr>
+              <a:t>ExxonMobil is the only operator with a full-year 2027 plan - so it's the one refiner whose H2 we can confirm. Everyone else is H1-only.</a:t>
+            </a:r>
+          </a:p>
+        </p:txBody>
+      </p:sp>
+      <p:sp>
+        <p:nvSpPr>
+          <p:cNvPr id="10" name="Rectangle 9"/>
+          <p:cNvSpPr/>
+          <p:nvPr/>
+        </p:nvSpPr>
+        <p:spPr>
+          <a:xfrm>
+            <a:off x="8686800" y="2663952"/>
+            <a:ext cx="82296" cy="82296"/>
+          </a:xfrm>
+          <a:prstGeom prst="rect">
+            <a:avLst/>
+          </a:prstGeom>
+          <a:solidFill>
+            <a:srgbClr val="BF9000"/>
+          </a:solidFill>
+          <a:ln>
+            <a:noFill/>
+          </a:ln>
+          <a:effectLst/>
+        </p:spPr>
+        <p:style>
+          <a:lnRef idx="1">
+            <a:schemeClr val="accent1"/>
+          </a:lnRef>
+          <a:fillRef idx="3">
+            <a:schemeClr val="accent1"/>
+          </a:fillRef>
+          <a:effectRef idx="2">
+            <a:schemeClr val="accent1"/>
+          </a:effectRef>
+          <a:fontRef idx="minor">
+            <a:schemeClr val="lt1"/>
+          </a:fontRef>
+        </p:style>
+        <p:txBody>
+          <a:bodyPr rtlCol="0" anchor="ctr"/>
+          <a:lstStyle/>
+          <a:p>
+            <a:pPr algn="ctr"/>
+          </a:p>
+        </p:txBody>
+      </p:sp>
+      <p:sp>
+        <p:nvSpPr>
+          <p:cNvPr id="11" name="TextBox 10"/>
+          <p:cNvSpPr txBox="1"/>
+          <p:nvPr/>
+        </p:nvSpPr>
+        <p:spPr>
+          <a:xfrm>
+            <a:off x="8887968" y="2599944"/>
+            <a:ext cx="3090672" cy="1042416"/>
+          </a:xfrm>
+          <a:prstGeom prst="rect">
+            <a:avLst/>
+          </a:prstGeom>
+          <a:noFill/>
+        </p:spPr>
+        <p:txBody>
+          <a:bodyPr wrap="square" anchor="t" lIns="12700" rIns="12700" tIns="12700" bIns="12700">
+            <a:spAutoFit/>
+          </a:bodyPr>
+          <a:lstStyle/>
+          <a:p>
+            <a:pPr algn="l">
+              <a:spcAft>
+                <a:spcPts val="300"/>
+              </a:spcAft>
+            </a:pPr>
+            <a:r>
+              <a:rPr sz="1100" b="0" i="0">
+                <a:solidFill>
+                  <a:srgbClr val="262B33"/>
+                </a:solidFill>
+                <a:latin typeface="Arial"/>
+              </a:rPr>
+              <a:t>Per unit, never summed - the 'Exxon ~700 kbd' figure was 8 Joliet units in one April turnaround added together; it's really ~250 kbd of crude.</a:t>
+            </a:r>
+          </a:p>
+        </p:txBody>
+      </p:sp>
+      <p:sp>
+        <p:nvSpPr>
+          <p:cNvPr id="12" name="Rectangle 11"/>
+          <p:cNvSpPr/>
+          <p:nvPr/>
+        </p:nvSpPr>
+        <p:spPr>
+          <a:xfrm>
+            <a:off x="8686800" y="3480816"/>
+            <a:ext cx="82296" cy="82296"/>
+          </a:xfrm>
+          <a:prstGeom prst="rect">
+            <a:avLst/>
+          </a:prstGeom>
+          <a:solidFill>
+            <a:srgbClr val="BF9000"/>
+          </a:solidFill>
+          <a:ln>
+            <a:noFill/>
+          </a:ln>
+          <a:effectLst/>
+        </p:spPr>
+        <p:style>
+          <a:lnRef idx="1">
+            <a:schemeClr val="accent1"/>
+          </a:lnRef>
+          <a:fillRef idx="3">
+            <a:schemeClr val="accent1"/>
+          </a:fillRef>
+          <a:effectRef idx="2">
+            <a:schemeClr val="accent1"/>
+          </a:effectRef>
+          <a:fontRef idx="minor">
+            <a:schemeClr val="lt1"/>
+          </a:fontRef>
+        </p:style>
+        <p:txBody>
+          <a:bodyPr rtlCol="0" anchor="ctr"/>
+          <a:lstStyle/>
+          <a:p>
+            <a:pPr algn="ctr"/>
+          </a:p>
+        </p:txBody>
+      </p:sp>
+      <p:sp>
+        <p:nvSpPr>
+          <p:cNvPr id="13" name="TextBox 12"/>
+          <p:cNvSpPr txBox="1"/>
+          <p:nvPr/>
+        </p:nvSpPr>
+        <p:spPr>
+          <a:xfrm>
+            <a:off x="8887968" y="3416808"/>
+            <a:ext cx="3090672" cy="1042416"/>
+          </a:xfrm>
+          <a:prstGeom prst="rect">
+            <a:avLst/>
+          </a:prstGeom>
+          <a:noFill/>
+        </p:spPr>
+        <p:txBody>
+          <a:bodyPr wrap="square" anchor="t" lIns="12700" rIns="12700" tIns="12700" bIns="12700">
+            <a:spAutoFit/>
+          </a:bodyPr>
+          <a:lstStyle/>
+          <a:p>
+            <a:pPr algn="l">
+              <a:spcAft>
+                <a:spcPts val="300"/>
+              </a:spcAft>
+            </a:pPr>
+            <a:r>
+              <a:rPr sz="1100" b="0" i="0">
+                <a:solidFill>
+                  <a:srgbClr val="262B33"/>
+                </a:solidFill>
+                <a:latin typeface="Arial"/>
+              </a:rPr>
+              <a:t>Reconciled to Exxon's own corporate plan (7 units): Baytown &amp; Beaumont FCC in Q1, Joliet crude Apr-May, Baton Rouge crude in autumn.</a:t>
+            </a:r>
+          </a:p>
+        </p:txBody>
+      </p:sp>
+      <p:sp>
+        <p:nvSpPr>
+          <p:cNvPr id="14" name="TextBox 13"/>
+          <p:cNvSpPr txBox="1"/>
+          <p:nvPr/>
+        </p:nvSpPr>
+        <p:spPr>
+          <a:xfrm>
+            <a:off x="457200" y="6163056"/>
+            <a:ext cx="10515600" cy="219456"/>
+          </a:xfrm>
+          <a:prstGeom prst="rect">
+            <a:avLst/>
+          </a:prstGeom>
+          <a:noFill/>
+        </p:spPr>
+        <p:txBody>
+          <a:bodyPr wrap="square" anchor="t" lIns="12700" rIns="12700" tIns="12700" bIns="12700">
+            <a:spAutoFit/>
+          </a:bodyPr>
+          <a:lstStyle/>
+          <a:p>
+            <a:pPr algn="l">
+              <a:spcAft>
+                <a:spcPts val="300"/>
+              </a:spcAft>
+            </a:pPr>
+            <a:r>
+              <a:rPr sz="800" b="0" i="1">
+                <a:solidFill>
+                  <a:srgbClr val="595959"/>
+                </a:solidFill>
+                <a:latin typeface="Arial"/>
+              </a:rPr>
+              <a:t>Cross-checked against ExxonMobil's corporate turnaround plan; match = same refinery + unit class, overlapping months.</a:t>
+            </a:r>
+          </a:p>
+        </p:txBody>
+      </p:sp>
+    </p:spTree>
+  </p:cSld>
+  <p:clrMapOvr>
+    <a:masterClrMapping/>
+  </p:clrMapOvr>
+</p:sld>
+</file>
+
+<file path=ppt/slides/slide6.xml><?xml version="1.0" encoding="utf-8"?>
+<p:sld xmlns:a="http://schemas.openxmlformats.org/drawingml/2006/main" xmlns:p="http://schemas.openxmlformats.org/presentationml/2006/main" xmlns:r="http://schemas.openxmlformats.org/officeDocument/2006/relationships">
+  <p:cSld>
+    <p:spTree>
+      <p:nvGrpSpPr>
+        <p:cNvPr id="1" name=""/>
+        <p:cNvGrpSpPr/>
+        <p:nvPr/>
+      </p:nvGrpSpPr>
+      <p:grpSpPr/>
+      <p:sp>
+        <p:nvSpPr>
+          <p:cNvPr id="2" name="TextBox 1"/>
+          <p:cNvSpPr txBox="1"/>
+          <p:nvPr/>
+        </p:nvSpPr>
+        <p:spPr>
+          <a:xfrm>
+            <a:off x="411480" y="164592"/>
+            <a:ext cx="11338560" cy="640080"/>
+          </a:xfrm>
+          <a:prstGeom prst="rect">
+            <a:avLst/>
+          </a:prstGeom>
+          <a:noFill/>
+        </p:spPr>
+        <p:txBody>
+          <a:bodyPr wrap="square" anchor="ctr" lIns="12700" rIns="12700" tIns="12700" bIns="12700">
+            <a:spAutoFit/>
+          </a:bodyPr>
+          <a:lstStyle/>
+          <a:p>
+            <a:pPr algn="l">
+              <a:spcAft>
+                <a:spcPts val="300"/>
+              </a:spcAft>
+            </a:pPr>
+            <a:r>
+              <a:rPr sz="3000" b="0" i="0">
+                <a:solidFill>
+                  <a:srgbClr val="C00000"/>
+                </a:solidFill>
+                <a:latin typeface="Arial"/>
+              </a:rPr>
               <a:t>2027 Unplanned Scenario - the Risk on Top of Planned</a:t>
             </a:r>
           </a:p>
@@ -11628,7 +12237,7 @@
                 </a:solidFill>
                 <a:latin typeface="Arial"/>
               </a:rPr>
-              <a:t>4</a:t>
+              <a:t>5</a:t>
             </a:r>
           </a:p>
         </p:txBody>

</xml_diff>

<commit_message>
Add H1 planned-per-unit slide: 2025 vs 2026 vs 2027 (like-for-like)
New slide 4: grouped bars of H1 (Jan-Jun) planned offline per focus unit for
2025, 2026 and 2027 - the honest cross-year read, since 2027's book is
confirmed only through H1. Metric is the day-weighted average kbd offline
across Jan-Jun (planned only), each unit counted once per month, never summed
across classes. The booked 2027 H1 slate is materially heavier than the prior
two years in every unit (CDU ~548 vs ~325 in 2026; FCC ~256 vs ~98). Engine
gains h1_focus_planned(); bullets are data-driven (CDU y/y, heaviest unit) so
they stay correct on refresh. Deck is now 7 slides.

Co-Authored-By: Claude Opus 4.8 <noreply@anthropic.com>
Claude-Session: https://claude.ai/code/session_015p5NLGbwXS8USzMXyom8VW
</commit_message>
<xml_diff>
--- a/output/outage_deck.pptx
+++ b/output/outage_deck.pptx
@@ -11,6 +11,7 @@
     <p:sldId id="259" r:id="rId10"/>
     <p:sldId id="260" r:id="rId11"/>
     <p:sldId id="261" r:id="rId12"/>
+    <p:sldId id="262" r:id="rId13"/>
   </p:sldIdLst>
   <p:sldSz cx="12191695" cy="6858000" type="screen4x3"/>
   <p:notesSz cx="6858000" cy="9144000"/>
@@ -10963,7 +10964,7 @@
                 </a:solidFill>
                 <a:latin typeface="Arial"/>
               </a:rPr>
-              <a:t>Outages by PADD by Unit - Where It Tightens</a:t>
+              <a:t>H1 Planned Outages per Unit - 2025 / 2026 / 2027</a:t>
             </a:r>
           </a:p>
         </p:txBody>
@@ -11002,7 +11003,7 @@
                 </a:solidFill>
                 <a:latin typeface="Arial"/>
               </a:rPr>
-              <a:t>2027 crude (CDU, top) and cat-cracker (FCC, bottom) offline by region &amp; month</a:t>
+              <a:t>Like-for-like Jan-Jun planned offline, per unit (2027's book is confirmed through H1)</a:t>
             </a:r>
           </a:p>
         </p:txBody>
@@ -11087,7 +11088,7 @@
       </p:sp>
       <p:pic>
         <p:nvPicPr>
-          <p:cNvPr id="6" name="Picture 5" descr="cdu_padd_27.png"/>
+          <p:cNvPr id="6" name="Picture 5" descr="h1_by_unit.png"/>
           <p:cNvPicPr>
             <a:picLocks noChangeAspect="1"/>
           </p:cNvPicPr>
@@ -11101,41 +11102,17 @@
         </p:blipFill>
         <p:spPr>
           <a:xfrm>
-            <a:off x="1652456" y="1234440"/>
-            <a:ext cx="4284608" cy="2331720"/>
+            <a:off x="411480" y="2046022"/>
+            <a:ext cx="6766560" cy="3131716"/>
           </a:xfrm>
           <a:prstGeom prst="rect">
             <a:avLst/>
           </a:prstGeom>
         </p:spPr>
       </p:pic>
-      <p:pic>
-        <p:nvPicPr>
-          <p:cNvPr id="7" name="Picture 6" descr="fcc_padd_27.png"/>
-          <p:cNvPicPr>
-            <a:picLocks noChangeAspect="1"/>
-          </p:cNvPicPr>
-          <p:nvPr/>
-        </p:nvPicPr>
-        <p:blipFill>
-          <a:blip r:embed="rId3"/>
-          <a:stretch>
-            <a:fillRect/>
-          </a:stretch>
-        </p:blipFill>
-        <p:spPr>
-          <a:xfrm>
-            <a:off x="1655392" y="3703320"/>
-            <a:ext cx="4278735" cy="2331720"/>
-          </a:xfrm>
-          <a:prstGeom prst="rect">
-            <a:avLst/>
-          </a:prstGeom>
-        </p:spPr>
-      </p:pic>
-      <p:sp>
-        <p:nvSpPr>
-          <p:cNvPr id="8" name="TextBox 7"/>
+      <p:sp>
+        <p:nvSpPr>
+          <p:cNvPr id="7" name="TextBox 6"/>
           <p:cNvSpPr txBox="1"/>
           <p:nvPr/>
         </p:nvSpPr>
@@ -11174,7 +11151,7 @@
       </p:sp>
       <p:sp>
         <p:nvSpPr>
-          <p:cNvPr id="9" name="Rectangle 8"/>
+          <p:cNvPr id="8" name="Rectangle 7"/>
           <p:cNvSpPr/>
           <p:nvPr/>
         </p:nvSpPr>
@@ -11218,14 +11195,14 @@
       </p:sp>
       <p:sp>
         <p:nvSpPr>
-          <p:cNvPr id="10" name="TextBox 9"/>
+          <p:cNvPr id="9" name="TextBox 8"/>
           <p:cNvSpPr txBox="1"/>
           <p:nvPr/>
         </p:nvSpPr>
         <p:spPr>
           <a:xfrm>
             <a:off x="7653528" y="1783080"/>
-            <a:ext cx="4233672" cy="804672"/>
+            <a:ext cx="4233672" cy="1042416"/>
           </a:xfrm>
           <a:prstGeom prst="rect">
             <a:avLst/>
@@ -11250,20 +11227,20 @@
                 </a:solidFill>
                 <a:latin typeface="Arial"/>
               </a:rPr>
-              <a:t>PADD 3 (Gulf) is the swing region - most crude and FCC work lands there, tightening USGC supply and the export barrel.</a:t>
+              <a:t>H1 is the only honest cross-year read for 2027: the book is confirmed through June; H2 is still being scheduled, so a full-year comparison would understate 2027.</a:t>
             </a:r>
           </a:p>
         </p:txBody>
       </p:sp>
       <p:sp>
         <p:nvSpPr>
-          <p:cNvPr id="11" name="Rectangle 10"/>
-          <p:cNvSpPr/>
-          <p:nvPr/>
-        </p:nvSpPr>
-        <p:spPr>
-          <a:xfrm>
-            <a:off x="7452360" y="2542032"/>
+          <p:cNvPr id="10" name="Rectangle 9"/>
+          <p:cNvSpPr/>
+          <p:nvPr/>
+        </p:nvSpPr>
+        <p:spPr>
+          <a:xfrm>
+            <a:off x="7452360" y="2724912"/>
             <a:ext cx="82296" cy="82296"/>
           </a:xfrm>
           <a:prstGeom prst="rect">
@@ -11301,14 +11278,14 @@
       </p:sp>
       <p:sp>
         <p:nvSpPr>
-          <p:cNvPr id="12" name="TextBox 11"/>
+          <p:cNvPr id="11" name="TextBox 10"/>
           <p:cNvSpPr txBox="1"/>
           <p:nvPr/>
         </p:nvSpPr>
         <p:spPr>
           <a:xfrm>
-            <a:off x="7653528" y="2478024"/>
-            <a:ext cx="4233672" cy="804672"/>
+            <a:off x="7653528" y="2660904"/>
+            <a:ext cx="4233672" cy="566928"/>
           </a:xfrm>
           <a:prstGeom prst="rect">
             <a:avLst/>
@@ -11333,20 +11310,20 @@
                 </a:solidFill>
                 <a:latin typeface="Arial"/>
               </a:rPr>
-              <a:t>PADD 2 (Midwest) carries the spring crude (the Joliet event). PADD 5 (West) is islanded - a California outage doesn't get bailed out by other regions.</a:t>
+              <a:t>Crude (CDU): H1 2027 ~548 kbd vs ~325 in 2026 and ~393 in 2025 - heavier than last year (+68%).</a:t>
             </a:r>
           </a:p>
         </p:txBody>
       </p:sp>
       <p:sp>
         <p:nvSpPr>
-          <p:cNvPr id="13" name="Rectangle 12"/>
-          <p:cNvSpPr/>
-          <p:nvPr/>
-        </p:nvSpPr>
-        <p:spPr>
-          <a:xfrm>
-            <a:off x="7452360" y="3236976"/>
+          <p:cNvPr id="12" name="Rectangle 11"/>
+          <p:cNvSpPr/>
+          <p:nvPr/>
+        </p:nvSpPr>
+        <p:spPr>
+          <a:xfrm>
+            <a:off x="7452360" y="3291840"/>
             <a:ext cx="82296" cy="82296"/>
           </a:xfrm>
           <a:prstGeom prst="rect">
@@ -11384,13 +11361,13 @@
       </p:sp>
       <p:sp>
         <p:nvSpPr>
-          <p:cNvPr id="14" name="TextBox 13"/>
+          <p:cNvPr id="13" name="TextBox 12"/>
           <p:cNvSpPr txBox="1"/>
           <p:nvPr/>
         </p:nvSpPr>
         <p:spPr>
           <a:xfrm>
-            <a:off x="7653528" y="3172968"/>
+            <a:off x="7653528" y="3227832"/>
             <a:ext cx="4233672" cy="804672"/>
           </a:xfrm>
           <a:prstGeom prst="rect">
@@ -11416,20 +11393,20 @@
                 </a:solidFill>
                 <a:latin typeface="Arial"/>
               </a:rPr>
-              <a:t>Timing: spring (Mar-May) and autumn (Sep-Oct) are the windows; summer is protected for driving-season gasoline.</a:t>
+              <a:t>Heaviest booked H1 2027 slate: Crude (CDU), then FCC (cat cracker) - each unit read on its own, never added together.</a:t>
             </a:r>
           </a:p>
         </p:txBody>
       </p:sp>
       <p:sp>
         <p:nvSpPr>
-          <p:cNvPr id="15" name="Rectangle 14"/>
-          <p:cNvSpPr/>
-          <p:nvPr/>
-        </p:nvSpPr>
-        <p:spPr>
-          <a:xfrm>
-            <a:off x="7452360" y="3931920"/>
+          <p:cNvPr id="14" name="Rectangle 13"/>
+          <p:cNvSpPr/>
+          <p:nvPr/>
+        </p:nvSpPr>
+        <p:spPr>
+          <a:xfrm>
+            <a:off x="7452360" y="3986784"/>
             <a:ext cx="82296" cy="82296"/>
           </a:xfrm>
           <a:prstGeom prst="rect">
@@ -11467,13 +11444,13 @@
       </p:sp>
       <p:sp>
         <p:nvSpPr>
-          <p:cNvPr id="16" name="TextBox 15"/>
+          <p:cNvPr id="15" name="TextBox 14"/>
           <p:cNvSpPr txBox="1"/>
           <p:nvPr/>
         </p:nvSpPr>
         <p:spPr>
           <a:xfrm>
-            <a:off x="7653528" y="3867912"/>
+            <a:off x="7653528" y="3922776"/>
             <a:ext cx="4233672" cy="804672"/>
           </a:xfrm>
           <a:prstGeom prst="rect">
@@ -11499,14 +11476,14 @@
                 </a:solidFill>
                 <a:latin typeface="Arial"/>
               </a:rPr>
-              <a:t>Past the dotted line (H2) is non-Exxon-unconfirmed - those autumn bars are a floor and grow as operators book.</a:t>
+              <a:t>A heavier H1 = more crude / cat-cracker capacity in planned turnaround = tighter product supply through the spring window.</a:t>
             </a:r>
           </a:p>
         </p:txBody>
       </p:sp>
       <p:sp>
         <p:nvSpPr>
-          <p:cNvPr id="17" name="TextBox 16"/>
+          <p:cNvPr id="16" name="TextBox 15"/>
           <p:cNvSpPr txBox="1"/>
           <p:nvPr/>
         </p:nvSpPr>
@@ -11538,7 +11515,7 @@
                 </a:solidFill>
                 <a:latin typeface="Arial"/>
               </a:rPr>
-              <a:t>Day-weighted concurrent capacity offline by month, stacked by PADD. P1 NE, P2 Midwest, P3 Gulf, P4 Rockies, P5 West.</a:t>
+              <a:t>Day-weighted average capacity offline across Jan-Jun, planned only, each unit counted once per month. 2025/26 actuals; 2027 the booked plan.</a:t>
             </a:r>
           </a:p>
         </p:txBody>
@@ -11595,7 +11572,7 @@
                 </a:solidFill>
                 <a:latin typeface="Arial"/>
               </a:rPr>
-              <a:t>ExxonMobil 2027 - Per Unit</a:t>
+              <a:t>Outages by PADD by Unit - Where It Tightens</a:t>
             </a:r>
           </a:p>
         </p:txBody>
@@ -11634,7 +11611,7 @@
                 </a:solidFill>
                 <a:latin typeface="Arial"/>
               </a:rPr>
-              <a:t>Each unit's turnaround as its own bar, nameplate capacity offline (kbd)</a:t>
+              <a:t>2027 crude (CDU, top) and cat-cracker (FCC, bottom) offline by region &amp; month</a:t>
             </a:r>
           </a:p>
         </p:txBody>
@@ -11719,7 +11696,7 @@
       </p:sp>
       <p:pic>
         <p:nvPicPr>
-          <p:cNvPr id="6" name="Picture 5" descr="exxon_gantt.png"/>
+          <p:cNvPr id="6" name="Picture 5" descr="cdu_padd_27.png"/>
           <p:cNvPicPr>
             <a:picLocks noChangeAspect="1"/>
           </p:cNvPicPr>
@@ -11733,24 +11710,48 @@
         </p:blipFill>
         <p:spPr>
           <a:xfrm>
-            <a:off x="365760" y="1827060"/>
-            <a:ext cx="8138160" cy="3569640"/>
+            <a:off x="1652456" y="1234440"/>
+            <a:ext cx="4284608" cy="2331720"/>
           </a:xfrm>
           <a:prstGeom prst="rect">
             <a:avLst/>
           </a:prstGeom>
         </p:spPr>
       </p:pic>
-      <p:sp>
-        <p:nvSpPr>
-          <p:cNvPr id="7" name="TextBox 6"/>
+      <p:pic>
+        <p:nvPicPr>
+          <p:cNvPr id="7" name="Picture 6" descr="fcc_padd_27.png"/>
+          <p:cNvPicPr>
+            <a:picLocks noChangeAspect="1"/>
+          </p:cNvPicPr>
+          <p:nvPr/>
+        </p:nvPicPr>
+        <p:blipFill>
+          <a:blip r:embed="rId3"/>
+          <a:stretch>
+            <a:fillRect/>
+          </a:stretch>
+        </p:blipFill>
+        <p:spPr>
+          <a:xfrm>
+            <a:off x="1655392" y="3703320"/>
+            <a:ext cx="4278735" cy="2331720"/>
+          </a:xfrm>
+          <a:prstGeom prst="rect">
+            <a:avLst/>
+          </a:prstGeom>
+        </p:spPr>
+      </p:pic>
+      <p:sp>
+        <p:nvSpPr>
+          <p:cNvPr id="8" name="TextBox 7"/>
           <p:cNvSpPr txBox="1"/>
           <p:nvPr/>
         </p:nvSpPr>
         <p:spPr>
           <a:xfrm>
-            <a:off x="8686800" y="1371600"/>
-            <a:ext cx="3291840" cy="274320"/>
+            <a:off x="7452360" y="1371600"/>
+            <a:ext cx="4434840" cy="274320"/>
           </a:xfrm>
           <a:prstGeom prst="rect">
             <a:avLst/>
@@ -11769,7 +11770,7 @@
               </a:spcAft>
             </a:pPr>
             <a:r>
-              <a:rPr sz="1250" b="1" i="0">
+              <a:rPr sz="1350" b="1" i="0">
                 <a:solidFill>
                   <a:srgbClr val="1F3864"/>
                 </a:solidFill>
@@ -11782,13 +11783,13 @@
       </p:sp>
       <p:sp>
         <p:nvSpPr>
-          <p:cNvPr id="8" name="Rectangle 7"/>
-          <p:cNvSpPr/>
-          <p:nvPr/>
-        </p:nvSpPr>
-        <p:spPr>
-          <a:xfrm>
-            <a:off x="8686800" y="1847088"/>
+          <p:cNvPr id="9" name="Rectangle 8"/>
+          <p:cNvSpPr/>
+          <p:nvPr/>
+        </p:nvSpPr>
+        <p:spPr>
+          <a:xfrm>
+            <a:off x="7452360" y="1847088"/>
             <a:ext cx="82296" cy="82296"/>
           </a:xfrm>
           <a:prstGeom prst="rect">
@@ -11826,14 +11827,14 @@
       </p:sp>
       <p:sp>
         <p:nvSpPr>
-          <p:cNvPr id="9" name="TextBox 8"/>
+          <p:cNvPr id="10" name="TextBox 9"/>
           <p:cNvSpPr txBox="1"/>
           <p:nvPr/>
         </p:nvSpPr>
         <p:spPr>
           <a:xfrm>
-            <a:off x="8887968" y="1783080"/>
-            <a:ext cx="3090672" cy="1042416"/>
+            <a:off x="7653528" y="1783080"/>
+            <a:ext cx="4233672" cy="804672"/>
           </a:xfrm>
           <a:prstGeom prst="rect">
             <a:avLst/>
@@ -11852,26 +11853,26 @@
               </a:spcAft>
             </a:pPr>
             <a:r>
-              <a:rPr sz="1100" b="0" i="0">
+              <a:rPr sz="1200" b="0" i="0">
                 <a:solidFill>
                   <a:srgbClr val="262B33"/>
                 </a:solidFill>
                 <a:latin typeface="Arial"/>
               </a:rPr>
-              <a:t>ExxonMobil is the only operator with a full-year 2027 plan - so it's the one refiner whose H2 we can confirm. Everyone else is H1-only.</a:t>
+              <a:t>PADD 3 (Gulf) is the swing region - most crude and FCC work lands there, tightening USGC supply and the export barrel.</a:t>
             </a:r>
           </a:p>
         </p:txBody>
       </p:sp>
       <p:sp>
         <p:nvSpPr>
-          <p:cNvPr id="10" name="Rectangle 9"/>
-          <p:cNvSpPr/>
-          <p:nvPr/>
-        </p:nvSpPr>
-        <p:spPr>
-          <a:xfrm>
-            <a:off x="8686800" y="2663952"/>
+          <p:cNvPr id="11" name="Rectangle 10"/>
+          <p:cNvSpPr/>
+          <p:nvPr/>
+        </p:nvSpPr>
+        <p:spPr>
+          <a:xfrm>
+            <a:off x="7452360" y="2542032"/>
             <a:ext cx="82296" cy="82296"/>
           </a:xfrm>
           <a:prstGeom prst="rect">
@@ -11909,14 +11910,14 @@
       </p:sp>
       <p:sp>
         <p:nvSpPr>
-          <p:cNvPr id="11" name="TextBox 10"/>
+          <p:cNvPr id="12" name="TextBox 11"/>
           <p:cNvSpPr txBox="1"/>
           <p:nvPr/>
         </p:nvSpPr>
         <p:spPr>
           <a:xfrm>
-            <a:off x="8887968" y="2599944"/>
-            <a:ext cx="3090672" cy="1042416"/>
+            <a:off x="7653528" y="2478024"/>
+            <a:ext cx="4233672" cy="804672"/>
           </a:xfrm>
           <a:prstGeom prst="rect">
             <a:avLst/>
@@ -11935,26 +11936,26 @@
               </a:spcAft>
             </a:pPr>
             <a:r>
-              <a:rPr sz="1100" b="0" i="0">
+              <a:rPr sz="1200" b="0" i="0">
                 <a:solidFill>
                   <a:srgbClr val="262B33"/>
                 </a:solidFill>
                 <a:latin typeface="Arial"/>
               </a:rPr>
-              <a:t>Per unit, never summed - the 'Exxon ~700 kbd' figure was 8 Joliet units in one April turnaround added together; it's really ~250 kbd of crude.</a:t>
+              <a:t>PADD 2 (Midwest) carries the spring crude (the Joliet event). PADD 5 (West) is islanded - a California outage doesn't get bailed out by other regions.</a:t>
             </a:r>
           </a:p>
         </p:txBody>
       </p:sp>
       <p:sp>
         <p:nvSpPr>
-          <p:cNvPr id="12" name="Rectangle 11"/>
-          <p:cNvSpPr/>
-          <p:nvPr/>
-        </p:nvSpPr>
-        <p:spPr>
-          <a:xfrm>
-            <a:off x="8686800" y="3480816"/>
+          <p:cNvPr id="13" name="Rectangle 12"/>
+          <p:cNvSpPr/>
+          <p:nvPr/>
+        </p:nvSpPr>
+        <p:spPr>
+          <a:xfrm>
+            <a:off x="7452360" y="3236976"/>
             <a:ext cx="82296" cy="82296"/>
           </a:xfrm>
           <a:prstGeom prst="rect">
@@ -11992,14 +11993,14 @@
       </p:sp>
       <p:sp>
         <p:nvSpPr>
-          <p:cNvPr id="13" name="TextBox 12"/>
+          <p:cNvPr id="14" name="TextBox 13"/>
           <p:cNvSpPr txBox="1"/>
           <p:nvPr/>
         </p:nvSpPr>
         <p:spPr>
           <a:xfrm>
-            <a:off x="8887968" y="3416808"/>
-            <a:ext cx="3090672" cy="1042416"/>
+            <a:off x="7653528" y="3172968"/>
+            <a:ext cx="4233672" cy="804672"/>
           </a:xfrm>
           <a:prstGeom prst="rect">
             <a:avLst/>
@@ -12018,20 +12019,103 @@
               </a:spcAft>
             </a:pPr>
             <a:r>
-              <a:rPr sz="1100" b="0" i="0">
+              <a:rPr sz="1200" b="0" i="0">
                 <a:solidFill>
                   <a:srgbClr val="262B33"/>
                 </a:solidFill>
                 <a:latin typeface="Arial"/>
               </a:rPr>
-              <a:t>Reconciled to Exxon's own corporate plan (7 units): Baytown &amp; Beaumont FCC in Q1, Joliet crude Apr-May, Baton Rouge crude in autumn.</a:t>
+              <a:t>Timing: spring (Mar-May) and autumn (Sep-Oct) are the windows; summer is protected for driving-season gasoline.</a:t>
             </a:r>
           </a:p>
         </p:txBody>
       </p:sp>
       <p:sp>
         <p:nvSpPr>
-          <p:cNvPr id="14" name="TextBox 13"/>
+          <p:cNvPr id="15" name="Rectangle 14"/>
+          <p:cNvSpPr/>
+          <p:nvPr/>
+        </p:nvSpPr>
+        <p:spPr>
+          <a:xfrm>
+            <a:off x="7452360" y="3931920"/>
+            <a:ext cx="82296" cy="82296"/>
+          </a:xfrm>
+          <a:prstGeom prst="rect">
+            <a:avLst/>
+          </a:prstGeom>
+          <a:solidFill>
+            <a:srgbClr val="BF9000"/>
+          </a:solidFill>
+          <a:ln>
+            <a:noFill/>
+          </a:ln>
+          <a:effectLst/>
+        </p:spPr>
+        <p:style>
+          <a:lnRef idx="1">
+            <a:schemeClr val="accent1"/>
+          </a:lnRef>
+          <a:fillRef idx="3">
+            <a:schemeClr val="accent1"/>
+          </a:fillRef>
+          <a:effectRef idx="2">
+            <a:schemeClr val="accent1"/>
+          </a:effectRef>
+          <a:fontRef idx="minor">
+            <a:schemeClr val="lt1"/>
+          </a:fontRef>
+        </p:style>
+        <p:txBody>
+          <a:bodyPr rtlCol="0" anchor="ctr"/>
+          <a:lstStyle/>
+          <a:p>
+            <a:pPr algn="ctr"/>
+          </a:p>
+        </p:txBody>
+      </p:sp>
+      <p:sp>
+        <p:nvSpPr>
+          <p:cNvPr id="16" name="TextBox 15"/>
+          <p:cNvSpPr txBox="1"/>
+          <p:nvPr/>
+        </p:nvSpPr>
+        <p:spPr>
+          <a:xfrm>
+            <a:off x="7653528" y="3867912"/>
+            <a:ext cx="4233672" cy="804672"/>
+          </a:xfrm>
+          <a:prstGeom prst="rect">
+            <a:avLst/>
+          </a:prstGeom>
+          <a:noFill/>
+        </p:spPr>
+        <p:txBody>
+          <a:bodyPr wrap="square" anchor="t" lIns="12700" rIns="12700" tIns="12700" bIns="12700">
+            <a:spAutoFit/>
+          </a:bodyPr>
+          <a:lstStyle/>
+          <a:p>
+            <a:pPr algn="l">
+              <a:spcAft>
+                <a:spcPts val="300"/>
+              </a:spcAft>
+            </a:pPr>
+            <a:r>
+              <a:rPr sz="1200" b="0" i="0">
+                <a:solidFill>
+                  <a:srgbClr val="262B33"/>
+                </a:solidFill>
+                <a:latin typeface="Arial"/>
+              </a:rPr>
+              <a:t>Past the dotted line (H2) is non-Exxon-unconfirmed - those autumn bars are a floor and grow as operators book.</a:t>
+            </a:r>
+          </a:p>
+        </p:txBody>
+      </p:sp>
+      <p:sp>
+        <p:nvSpPr>
+          <p:cNvPr id="17" name="TextBox 16"/>
           <p:cNvSpPr txBox="1"/>
           <p:nvPr/>
         </p:nvSpPr>
@@ -12063,7 +12147,7 @@
                 </a:solidFill>
                 <a:latin typeface="Arial"/>
               </a:rPr>
-              <a:t>Cross-checked against ExxonMobil's corporate turnaround plan; match = same refinery + unit class, overlapping months.</a:t>
+              <a:t>Day-weighted concurrent capacity offline by month, stacked by PADD. P1 NE, P2 Midwest, P3 Gulf, P4 Rockies, P5 West.</a:t>
             </a:r>
           </a:p>
         </p:txBody>
@@ -12120,6 +12204,531 @@
                 </a:solidFill>
                 <a:latin typeface="Arial"/>
               </a:rPr>
+              <a:t>ExxonMobil 2027 - Per Unit</a:t>
+            </a:r>
+          </a:p>
+        </p:txBody>
+      </p:sp>
+      <p:sp>
+        <p:nvSpPr>
+          <p:cNvPr id="3" name="TextBox 2"/>
+          <p:cNvSpPr txBox="1"/>
+          <p:nvPr/>
+        </p:nvSpPr>
+        <p:spPr>
+          <a:xfrm>
+            <a:off x="457200" y="841248"/>
+            <a:ext cx="11247120" cy="274320"/>
+          </a:xfrm>
+          <a:prstGeom prst="rect">
+            <a:avLst/>
+          </a:prstGeom>
+          <a:noFill/>
+        </p:spPr>
+        <p:txBody>
+          <a:bodyPr wrap="square" anchor="t" lIns="12700" rIns="12700" tIns="12700" bIns="12700">
+            <a:spAutoFit/>
+          </a:bodyPr>
+          <a:lstStyle/>
+          <a:p>
+            <a:pPr algn="l">
+              <a:spcAft>
+                <a:spcPts val="300"/>
+              </a:spcAft>
+            </a:pPr>
+            <a:r>
+              <a:rPr sz="1200" b="0" i="0">
+                <a:solidFill>
+                  <a:srgbClr val="595959"/>
+                </a:solidFill>
+                <a:latin typeface="Arial"/>
+              </a:rPr>
+              <a:t>Each unit's turnaround as its own bar, nameplate capacity offline (kbd)</a:t>
+            </a:r>
+          </a:p>
+        </p:txBody>
+      </p:sp>
+      <p:sp>
+        <p:nvSpPr>
+          <p:cNvPr id="4" name="TextBox 3"/>
+          <p:cNvSpPr txBox="1"/>
+          <p:nvPr/>
+        </p:nvSpPr>
+        <p:spPr>
+          <a:xfrm>
+            <a:off x="411480" y="6382512"/>
+            <a:ext cx="2743200" cy="292608"/>
+          </a:xfrm>
+          <a:prstGeom prst="rect">
+            <a:avLst/>
+          </a:prstGeom>
+          <a:noFill/>
+        </p:spPr>
+        <p:txBody>
+          <a:bodyPr wrap="square" anchor="ctr" lIns="12700" rIns="12700" tIns="12700" bIns="12700">
+            <a:spAutoFit/>
+          </a:bodyPr>
+          <a:lstStyle/>
+          <a:p>
+            <a:pPr algn="l">
+              <a:spcAft>
+                <a:spcPts val="300"/>
+              </a:spcAft>
+            </a:pPr>
+            <a:r>
+              <a:rPr sz="1300" b="1" i="0">
+                <a:solidFill>
+                  <a:srgbClr val="C00000"/>
+                </a:solidFill>
+                <a:latin typeface="Arial"/>
+              </a:rPr>
+              <a:t>Products Trading</a:t>
+            </a:r>
+          </a:p>
+        </p:txBody>
+      </p:sp>
+      <p:sp>
+        <p:nvSpPr>
+          <p:cNvPr id="5" name="TextBox 4"/>
+          <p:cNvSpPr txBox="1"/>
+          <p:nvPr/>
+        </p:nvSpPr>
+        <p:spPr>
+          <a:xfrm>
+            <a:off x="11430000" y="6400800"/>
+            <a:ext cx="640080" cy="274320"/>
+          </a:xfrm>
+          <a:prstGeom prst="rect">
+            <a:avLst/>
+          </a:prstGeom>
+          <a:noFill/>
+        </p:spPr>
+        <p:txBody>
+          <a:bodyPr wrap="square" anchor="t" lIns="12700" rIns="12700" tIns="12700" bIns="12700">
+            <a:spAutoFit/>
+          </a:bodyPr>
+          <a:lstStyle/>
+          <a:p>
+            <a:pPr algn="r">
+              <a:spcAft>
+                <a:spcPts val="300"/>
+              </a:spcAft>
+            </a:pPr>
+            <a:r>
+              <a:rPr sz="900" b="0" i="0">
+                <a:solidFill>
+                  <a:srgbClr val="595959"/>
+                </a:solidFill>
+                <a:latin typeface="Arial"/>
+              </a:rPr>
+              <a:t>5</a:t>
+            </a:r>
+          </a:p>
+        </p:txBody>
+      </p:sp>
+      <p:pic>
+        <p:nvPicPr>
+          <p:cNvPr id="6" name="Picture 5" descr="exxon_gantt.png"/>
+          <p:cNvPicPr>
+            <a:picLocks noChangeAspect="1"/>
+          </p:cNvPicPr>
+          <p:nvPr/>
+        </p:nvPicPr>
+        <p:blipFill>
+          <a:blip r:embed="rId2"/>
+          <a:stretch>
+            <a:fillRect/>
+          </a:stretch>
+        </p:blipFill>
+        <p:spPr>
+          <a:xfrm>
+            <a:off x="365760" y="1827060"/>
+            <a:ext cx="8138160" cy="3569640"/>
+          </a:xfrm>
+          <a:prstGeom prst="rect">
+            <a:avLst/>
+          </a:prstGeom>
+        </p:spPr>
+      </p:pic>
+      <p:sp>
+        <p:nvSpPr>
+          <p:cNvPr id="7" name="TextBox 6"/>
+          <p:cNvSpPr txBox="1"/>
+          <p:nvPr/>
+        </p:nvSpPr>
+        <p:spPr>
+          <a:xfrm>
+            <a:off x="8686800" y="1371600"/>
+            <a:ext cx="3291840" cy="274320"/>
+          </a:xfrm>
+          <a:prstGeom prst="rect">
+            <a:avLst/>
+          </a:prstGeom>
+          <a:noFill/>
+        </p:spPr>
+        <p:txBody>
+          <a:bodyPr wrap="square" anchor="t" lIns="12700" rIns="12700" tIns="12700" bIns="12700">
+            <a:spAutoFit/>
+          </a:bodyPr>
+          <a:lstStyle/>
+          <a:p>
+            <a:pPr algn="l">
+              <a:spcAft>
+                <a:spcPts val="300"/>
+              </a:spcAft>
+            </a:pPr>
+            <a:r>
+              <a:rPr sz="1250" b="1" i="0">
+                <a:solidFill>
+                  <a:srgbClr val="1F3864"/>
+                </a:solidFill>
+                <a:latin typeface="Arial"/>
+              </a:rPr>
+              <a:t>Key takeaways:</a:t>
+            </a:r>
+          </a:p>
+        </p:txBody>
+      </p:sp>
+      <p:sp>
+        <p:nvSpPr>
+          <p:cNvPr id="8" name="Rectangle 7"/>
+          <p:cNvSpPr/>
+          <p:nvPr/>
+        </p:nvSpPr>
+        <p:spPr>
+          <a:xfrm>
+            <a:off x="8686800" y="1847088"/>
+            <a:ext cx="82296" cy="82296"/>
+          </a:xfrm>
+          <a:prstGeom prst="rect">
+            <a:avLst/>
+          </a:prstGeom>
+          <a:solidFill>
+            <a:srgbClr val="BF9000"/>
+          </a:solidFill>
+          <a:ln>
+            <a:noFill/>
+          </a:ln>
+          <a:effectLst/>
+        </p:spPr>
+        <p:style>
+          <a:lnRef idx="1">
+            <a:schemeClr val="accent1"/>
+          </a:lnRef>
+          <a:fillRef idx="3">
+            <a:schemeClr val="accent1"/>
+          </a:fillRef>
+          <a:effectRef idx="2">
+            <a:schemeClr val="accent1"/>
+          </a:effectRef>
+          <a:fontRef idx="minor">
+            <a:schemeClr val="lt1"/>
+          </a:fontRef>
+        </p:style>
+        <p:txBody>
+          <a:bodyPr rtlCol="0" anchor="ctr"/>
+          <a:lstStyle/>
+          <a:p>
+            <a:pPr algn="ctr"/>
+          </a:p>
+        </p:txBody>
+      </p:sp>
+      <p:sp>
+        <p:nvSpPr>
+          <p:cNvPr id="9" name="TextBox 8"/>
+          <p:cNvSpPr txBox="1"/>
+          <p:nvPr/>
+        </p:nvSpPr>
+        <p:spPr>
+          <a:xfrm>
+            <a:off x="8887968" y="1783080"/>
+            <a:ext cx="3090672" cy="1042416"/>
+          </a:xfrm>
+          <a:prstGeom prst="rect">
+            <a:avLst/>
+          </a:prstGeom>
+          <a:noFill/>
+        </p:spPr>
+        <p:txBody>
+          <a:bodyPr wrap="square" anchor="t" lIns="12700" rIns="12700" tIns="12700" bIns="12700">
+            <a:spAutoFit/>
+          </a:bodyPr>
+          <a:lstStyle/>
+          <a:p>
+            <a:pPr algn="l">
+              <a:spcAft>
+                <a:spcPts val="300"/>
+              </a:spcAft>
+            </a:pPr>
+            <a:r>
+              <a:rPr sz="1100" b="0" i="0">
+                <a:solidFill>
+                  <a:srgbClr val="262B33"/>
+                </a:solidFill>
+                <a:latin typeface="Arial"/>
+              </a:rPr>
+              <a:t>ExxonMobil is the only operator with a full-year 2027 plan - so it's the one refiner whose H2 we can confirm. Everyone else is H1-only.</a:t>
+            </a:r>
+          </a:p>
+        </p:txBody>
+      </p:sp>
+      <p:sp>
+        <p:nvSpPr>
+          <p:cNvPr id="10" name="Rectangle 9"/>
+          <p:cNvSpPr/>
+          <p:nvPr/>
+        </p:nvSpPr>
+        <p:spPr>
+          <a:xfrm>
+            <a:off x="8686800" y="2663952"/>
+            <a:ext cx="82296" cy="82296"/>
+          </a:xfrm>
+          <a:prstGeom prst="rect">
+            <a:avLst/>
+          </a:prstGeom>
+          <a:solidFill>
+            <a:srgbClr val="BF9000"/>
+          </a:solidFill>
+          <a:ln>
+            <a:noFill/>
+          </a:ln>
+          <a:effectLst/>
+        </p:spPr>
+        <p:style>
+          <a:lnRef idx="1">
+            <a:schemeClr val="accent1"/>
+          </a:lnRef>
+          <a:fillRef idx="3">
+            <a:schemeClr val="accent1"/>
+          </a:fillRef>
+          <a:effectRef idx="2">
+            <a:schemeClr val="accent1"/>
+          </a:effectRef>
+          <a:fontRef idx="minor">
+            <a:schemeClr val="lt1"/>
+          </a:fontRef>
+        </p:style>
+        <p:txBody>
+          <a:bodyPr rtlCol="0" anchor="ctr"/>
+          <a:lstStyle/>
+          <a:p>
+            <a:pPr algn="ctr"/>
+          </a:p>
+        </p:txBody>
+      </p:sp>
+      <p:sp>
+        <p:nvSpPr>
+          <p:cNvPr id="11" name="TextBox 10"/>
+          <p:cNvSpPr txBox="1"/>
+          <p:nvPr/>
+        </p:nvSpPr>
+        <p:spPr>
+          <a:xfrm>
+            <a:off x="8887968" y="2599944"/>
+            <a:ext cx="3090672" cy="1042416"/>
+          </a:xfrm>
+          <a:prstGeom prst="rect">
+            <a:avLst/>
+          </a:prstGeom>
+          <a:noFill/>
+        </p:spPr>
+        <p:txBody>
+          <a:bodyPr wrap="square" anchor="t" lIns="12700" rIns="12700" tIns="12700" bIns="12700">
+            <a:spAutoFit/>
+          </a:bodyPr>
+          <a:lstStyle/>
+          <a:p>
+            <a:pPr algn="l">
+              <a:spcAft>
+                <a:spcPts val="300"/>
+              </a:spcAft>
+            </a:pPr>
+            <a:r>
+              <a:rPr sz="1100" b="0" i="0">
+                <a:solidFill>
+                  <a:srgbClr val="262B33"/>
+                </a:solidFill>
+                <a:latin typeface="Arial"/>
+              </a:rPr>
+              <a:t>Per unit, never summed - the 'Exxon ~700 kbd' figure was 8 Joliet units in one April turnaround added together; it's really ~250 kbd of crude.</a:t>
+            </a:r>
+          </a:p>
+        </p:txBody>
+      </p:sp>
+      <p:sp>
+        <p:nvSpPr>
+          <p:cNvPr id="12" name="Rectangle 11"/>
+          <p:cNvSpPr/>
+          <p:nvPr/>
+        </p:nvSpPr>
+        <p:spPr>
+          <a:xfrm>
+            <a:off x="8686800" y="3480816"/>
+            <a:ext cx="82296" cy="82296"/>
+          </a:xfrm>
+          <a:prstGeom prst="rect">
+            <a:avLst/>
+          </a:prstGeom>
+          <a:solidFill>
+            <a:srgbClr val="BF9000"/>
+          </a:solidFill>
+          <a:ln>
+            <a:noFill/>
+          </a:ln>
+          <a:effectLst/>
+        </p:spPr>
+        <p:style>
+          <a:lnRef idx="1">
+            <a:schemeClr val="accent1"/>
+          </a:lnRef>
+          <a:fillRef idx="3">
+            <a:schemeClr val="accent1"/>
+          </a:fillRef>
+          <a:effectRef idx="2">
+            <a:schemeClr val="accent1"/>
+          </a:effectRef>
+          <a:fontRef idx="minor">
+            <a:schemeClr val="lt1"/>
+          </a:fontRef>
+        </p:style>
+        <p:txBody>
+          <a:bodyPr rtlCol="0" anchor="ctr"/>
+          <a:lstStyle/>
+          <a:p>
+            <a:pPr algn="ctr"/>
+          </a:p>
+        </p:txBody>
+      </p:sp>
+      <p:sp>
+        <p:nvSpPr>
+          <p:cNvPr id="13" name="TextBox 12"/>
+          <p:cNvSpPr txBox="1"/>
+          <p:nvPr/>
+        </p:nvSpPr>
+        <p:spPr>
+          <a:xfrm>
+            <a:off x="8887968" y="3416808"/>
+            <a:ext cx="3090672" cy="1042416"/>
+          </a:xfrm>
+          <a:prstGeom prst="rect">
+            <a:avLst/>
+          </a:prstGeom>
+          <a:noFill/>
+        </p:spPr>
+        <p:txBody>
+          <a:bodyPr wrap="square" anchor="t" lIns="12700" rIns="12700" tIns="12700" bIns="12700">
+            <a:spAutoFit/>
+          </a:bodyPr>
+          <a:lstStyle/>
+          <a:p>
+            <a:pPr algn="l">
+              <a:spcAft>
+                <a:spcPts val="300"/>
+              </a:spcAft>
+            </a:pPr>
+            <a:r>
+              <a:rPr sz="1100" b="0" i="0">
+                <a:solidFill>
+                  <a:srgbClr val="262B33"/>
+                </a:solidFill>
+                <a:latin typeface="Arial"/>
+              </a:rPr>
+              <a:t>Reconciled to Exxon's own corporate plan (7 units): Baytown &amp; Beaumont FCC in Q1, Joliet crude Apr-May, Baton Rouge crude in autumn.</a:t>
+            </a:r>
+          </a:p>
+        </p:txBody>
+      </p:sp>
+      <p:sp>
+        <p:nvSpPr>
+          <p:cNvPr id="14" name="TextBox 13"/>
+          <p:cNvSpPr txBox="1"/>
+          <p:nvPr/>
+        </p:nvSpPr>
+        <p:spPr>
+          <a:xfrm>
+            <a:off x="457200" y="6163056"/>
+            <a:ext cx="10515600" cy="219456"/>
+          </a:xfrm>
+          <a:prstGeom prst="rect">
+            <a:avLst/>
+          </a:prstGeom>
+          <a:noFill/>
+        </p:spPr>
+        <p:txBody>
+          <a:bodyPr wrap="square" anchor="t" lIns="12700" rIns="12700" tIns="12700" bIns="12700">
+            <a:spAutoFit/>
+          </a:bodyPr>
+          <a:lstStyle/>
+          <a:p>
+            <a:pPr algn="l">
+              <a:spcAft>
+                <a:spcPts val="300"/>
+              </a:spcAft>
+            </a:pPr>
+            <a:r>
+              <a:rPr sz="800" b="0" i="1">
+                <a:solidFill>
+                  <a:srgbClr val="595959"/>
+                </a:solidFill>
+                <a:latin typeface="Arial"/>
+              </a:rPr>
+              <a:t>Cross-checked against ExxonMobil's corporate turnaround plan; match = same refinery + unit class, overlapping months.</a:t>
+            </a:r>
+          </a:p>
+        </p:txBody>
+      </p:sp>
+    </p:spTree>
+  </p:cSld>
+  <p:clrMapOvr>
+    <a:masterClrMapping/>
+  </p:clrMapOvr>
+</p:sld>
+</file>
+
+<file path=ppt/slides/slide7.xml><?xml version="1.0" encoding="utf-8"?>
+<p:sld xmlns:a="http://schemas.openxmlformats.org/drawingml/2006/main" xmlns:p="http://schemas.openxmlformats.org/presentationml/2006/main" xmlns:r="http://schemas.openxmlformats.org/officeDocument/2006/relationships">
+  <p:cSld>
+    <p:spTree>
+      <p:nvGrpSpPr>
+        <p:cNvPr id="1" name=""/>
+        <p:cNvGrpSpPr/>
+        <p:nvPr/>
+      </p:nvGrpSpPr>
+      <p:grpSpPr/>
+      <p:sp>
+        <p:nvSpPr>
+          <p:cNvPr id="2" name="TextBox 1"/>
+          <p:cNvSpPr txBox="1"/>
+          <p:nvPr/>
+        </p:nvSpPr>
+        <p:spPr>
+          <a:xfrm>
+            <a:off x="411480" y="164592"/>
+            <a:ext cx="11338560" cy="640080"/>
+          </a:xfrm>
+          <a:prstGeom prst="rect">
+            <a:avLst/>
+          </a:prstGeom>
+          <a:noFill/>
+        </p:spPr>
+        <p:txBody>
+          <a:bodyPr wrap="square" anchor="ctr" lIns="12700" rIns="12700" tIns="12700" bIns="12700">
+            <a:spAutoFit/>
+          </a:bodyPr>
+          <a:lstStyle/>
+          <a:p>
+            <a:pPr algn="l">
+              <a:spcAft>
+                <a:spcPts val="300"/>
+              </a:spcAft>
+            </a:pPr>
+            <a:r>
+              <a:rPr sz="3000" b="0" i="0">
+                <a:solidFill>
+                  <a:srgbClr val="C00000"/>
+                </a:solidFill>
+                <a:latin typeface="Arial"/>
+              </a:rPr>
               <a:t>2027 Unplanned Scenario - the Risk on Top of Planned</a:t>
             </a:r>
           </a:p>
@@ -12237,7 +12846,7 @@
                 </a:solidFill>
                 <a:latin typeface="Arial"/>
               </a:rPr>
-              <a:t>5</a:t>
+              <a:t>6</a:t>
             </a:r>
           </a:p>
         </p:txBody>

</xml_diff>

<commit_message>
H1 comparison: break out by unit AND month (2x2 small multiples)
Per request, the H1 slide now shows each of the four focus units month by
month (Jan-Jun) with a line per year - 2025/26/27 - instead of a single H1
average bar. 2x2 small multiples, per-panel y-axis so each unit's monthly
shape stays readable, day-weighted planned kbd. The booked 2027 line sits
above prior years through the Feb-Mar turnaround crest (CDU peaks ~1,063 in
Mar). Removed the now-unused grouped-bar helper. Deck stays 7 slides.

Co-Authored-By: Claude Opus 4.8 <noreply@anthropic.com>
Claude-Session: https://claude.ai/code/session_015p5NLGbwXS8USzMXyom8VW
</commit_message>
<xml_diff>
--- a/output/outage_deck.pptx
+++ b/output/outage_deck.pptx
@@ -10964,7 +10964,7 @@
                 </a:solidFill>
                 <a:latin typeface="Arial"/>
               </a:rPr>
-              <a:t>H1 Planned Outages per Unit - 2025 / 2026 / 2027</a:t>
+              <a:t>H1 Planned Outages per Unit &amp; Month - 2025 / 2026 / 2027</a:t>
             </a:r>
           </a:p>
         </p:txBody>
@@ -11003,7 +11003,7 @@
                 </a:solidFill>
                 <a:latin typeface="Arial"/>
               </a:rPr>
-              <a:t>Like-for-like Jan-Jun planned offline, per unit (2027's book is confirmed through H1)</a:t>
+              <a:t>Like-for-like Jan-Jun planned offline, broken out by unit and month (2027 confirmed through H1)</a:t>
             </a:r>
           </a:p>
         </p:txBody>
@@ -11088,7 +11088,7 @@
       </p:sp>
       <p:pic>
         <p:nvPicPr>
-          <p:cNvPr id="6" name="Picture 5" descr="h1_by_unit.png"/>
+          <p:cNvPr id="6" name="Picture 5" descr="h1_month_by_unit.png"/>
           <p:cNvPicPr>
             <a:picLocks noChangeAspect="1"/>
           </p:cNvPicPr>
@@ -11102,8 +11102,8 @@
         </p:blipFill>
         <p:spPr>
           <a:xfrm>
-            <a:off x="411480" y="2046022"/>
-            <a:ext cx="6766560" cy="3131716"/>
+            <a:off x="365760" y="1304205"/>
+            <a:ext cx="8138160" cy="4615350"/>
           </a:xfrm>
           <a:prstGeom prst="rect">
             <a:avLst/>
@@ -11118,8 +11118,8 @@
         </p:nvSpPr>
         <p:spPr>
           <a:xfrm>
-            <a:off x="7452360" y="1371600"/>
-            <a:ext cx="4434840" cy="274320"/>
+            <a:off x="8686800" y="1371600"/>
+            <a:ext cx="3291840" cy="274320"/>
           </a:xfrm>
           <a:prstGeom prst="rect">
             <a:avLst/>
@@ -11138,7 +11138,7 @@
               </a:spcAft>
             </a:pPr>
             <a:r>
-              <a:rPr sz="1350" b="1" i="0">
+              <a:rPr sz="1250" b="1" i="0">
                 <a:solidFill>
                   <a:srgbClr val="1F3864"/>
                 </a:solidFill>
@@ -11157,7 +11157,7 @@
         </p:nvSpPr>
         <p:spPr>
           <a:xfrm>
-            <a:off x="7452360" y="1847088"/>
+            <a:off x="8686800" y="1847088"/>
             <a:ext cx="82296" cy="82296"/>
           </a:xfrm>
           <a:prstGeom prst="rect">
@@ -11201,8 +11201,8 @@
         </p:nvSpPr>
         <p:spPr>
           <a:xfrm>
-            <a:off x="7653528" y="1783080"/>
-            <a:ext cx="4233672" cy="1042416"/>
+            <a:off x="8887968" y="1783080"/>
+            <a:ext cx="3090672" cy="804672"/>
           </a:xfrm>
           <a:prstGeom prst="rect">
             <a:avLst/>
@@ -11221,13 +11221,13 @@
               </a:spcAft>
             </a:pPr>
             <a:r>
-              <a:rPr sz="1200" b="0" i="0">
+              <a:rPr sz="1100" b="0" i="0">
                 <a:solidFill>
                   <a:srgbClr val="262B33"/>
                 </a:solidFill>
                 <a:latin typeface="Arial"/>
               </a:rPr>
-              <a:t>H1 is the only honest cross-year read for 2027: the book is confirmed through June; H2 is still being scheduled, so a full-year comparison would understate 2027.</a:t>
+              <a:t>H1 is the only honest cross-year read for 2027 - the book is confirmed through June; H2 is still being scheduled.</a:t>
             </a:r>
           </a:p>
         </p:txBody>
@@ -11240,7 +11240,7 @@
         </p:nvSpPr>
         <p:spPr>
           <a:xfrm>
-            <a:off x="7452360" y="2724912"/>
+            <a:off x="8686800" y="2496312"/>
             <a:ext cx="82296" cy="82296"/>
           </a:xfrm>
           <a:prstGeom prst="rect">
@@ -11284,8 +11284,8 @@
         </p:nvSpPr>
         <p:spPr>
           <a:xfrm>
-            <a:off x="7653528" y="2660904"/>
-            <a:ext cx="4233672" cy="566928"/>
+            <a:off x="8887968" y="2432304"/>
+            <a:ext cx="3090672" cy="804672"/>
           </a:xfrm>
           <a:prstGeom prst="rect">
             <a:avLst/>
@@ -11304,13 +11304,13 @@
               </a:spcAft>
             </a:pPr>
             <a:r>
-              <a:rPr sz="1200" b="0" i="0">
+              <a:rPr sz="1100" b="0" i="0">
                 <a:solidFill>
                   <a:srgbClr val="262B33"/>
                 </a:solidFill>
                 <a:latin typeface="Arial"/>
               </a:rPr>
-              <a:t>Crude (CDU): H1 2027 ~548 kbd vs ~325 in 2026 and ~393 in 2025 - heavier than last year (+68%).</a:t>
+              <a:t>2027 runs heavier than 2025 and 2026 in most H1 months across the units - the navy line sits on top.</a:t>
             </a:r>
           </a:p>
         </p:txBody>
@@ -11323,7 +11323,7 @@
         </p:nvSpPr>
         <p:spPr>
           <a:xfrm>
-            <a:off x="7452360" y="3291840"/>
+            <a:off x="8686800" y="3145536"/>
             <a:ext cx="82296" cy="82296"/>
           </a:xfrm>
           <a:prstGeom prst="rect">
@@ -11367,8 +11367,8 @@
         </p:nvSpPr>
         <p:spPr>
           <a:xfrm>
-            <a:off x="7653528" y="3227832"/>
-            <a:ext cx="4233672" cy="804672"/>
+            <a:off x="8887968" y="3081528"/>
+            <a:ext cx="3090672" cy="804672"/>
           </a:xfrm>
           <a:prstGeom prst="rect">
             <a:avLst/>
@@ -11387,13 +11387,13 @@
               </a:spcAft>
             </a:pPr>
             <a:r>
-              <a:rPr sz="1200" b="0" i="0">
+              <a:rPr sz="1100" b="0" i="0">
                 <a:solidFill>
                   <a:srgbClr val="262B33"/>
                 </a:solidFill>
                 <a:latin typeface="Arial"/>
               </a:rPr>
-              <a:t>Heaviest booked H1 2027 slate: Crude (CDU), then FCC (cat cracker) - each unit read on its own, never added together.</a:t>
+              <a:t>Crude (CDU) H1 averages ~548 kbd vs ~325 (2026) / ~393 (2025), and crests in Mar (~1,063 kbd) - the spring turnaround peak.</a:t>
             </a:r>
           </a:p>
         </p:txBody>
@@ -11406,7 +11406,7 @@
         </p:nvSpPr>
         <p:spPr>
           <a:xfrm>
-            <a:off x="7452360" y="3986784"/>
+            <a:off x="8686800" y="3794760"/>
             <a:ext cx="82296" cy="82296"/>
           </a:xfrm>
           <a:prstGeom prst="rect">
@@ -11450,8 +11450,8 @@
         </p:nvSpPr>
         <p:spPr>
           <a:xfrm>
-            <a:off x="7653528" y="3922776"/>
-            <a:ext cx="4233672" cy="804672"/>
+            <a:off x="8887968" y="3730752"/>
+            <a:ext cx="3090672" cy="804672"/>
           </a:xfrm>
           <a:prstGeom prst="rect">
             <a:avLst/>
@@ -11470,13 +11470,13 @@
               </a:spcAft>
             </a:pPr>
             <a:r>
-              <a:rPr sz="1200" b="0" i="0">
+              <a:rPr sz="1100" b="0" i="0">
                 <a:solidFill>
                   <a:srgbClr val="262B33"/>
                 </a:solidFill>
                 <a:latin typeface="Arial"/>
               </a:rPr>
-              <a:t>A heavier H1 = more crude / cat-cracker capacity in planned turnaround = tighter product supply through the spring window.</a:t>
+              <a:t>Read each unit and each month on its own, never added together - a heavier spring = tighter product supply.</a:t>
             </a:r>
           </a:p>
         </p:txBody>
@@ -11515,7 +11515,7 @@
                 </a:solidFill>
                 <a:latin typeface="Arial"/>
               </a:rPr>
-              <a:t>Day-weighted average capacity offline across Jan-Jun, planned only, each unit counted once per month. 2025/26 actuals; 2027 the booked plan.</a:t>
+              <a:t>Day-weighted capacity offline by month, planned only, each unit counted once per month. Per-panel y-axis. 2025/26 actuals; 2027 the booked plan.</a:t>
             </a:r>
           </a:p>
         </p:txBody>

</xml_diff>

<commit_message>
H1 comparison: grouped bars + brighter palette (easier to read)
Per request, the H1 per-unit-and-month panels are grouped bars (one bar per
year per month) instead of lines - far easier to compare years at a glance -
on a brighter, higher-contrast palette: 2025 bright blue, 2026 bright gold,
2027 bright orange. The 2027 bar clearly stands tallest through the Feb-Mar
turnaround crest across the units. Same day-weighted planned basis, per-panel
y-axis, each unit on its own.

Co-Authored-By: Claude Opus 4.8 <noreply@anthropic.com>
Claude-Session: https://claude.ai/code/session_015p5NLGbwXS8USzMXyom8VW
</commit_message>
<xml_diff>
--- a/output/outage_deck.pptx
+++ b/output/outage_deck.pptx
@@ -11102,8 +11102,8 @@
         </p:blipFill>
         <p:spPr>
           <a:xfrm>
-            <a:off x="365760" y="1304205"/>
-            <a:ext cx="8138160" cy="4615350"/>
+            <a:off x="365760" y="1306008"/>
+            <a:ext cx="8138160" cy="4611744"/>
           </a:xfrm>
           <a:prstGeom prst="rect">
             <a:avLst/>
@@ -11310,7 +11310,7 @@
                 </a:solidFill>
                 <a:latin typeface="Arial"/>
               </a:rPr>
-              <a:t>2027 runs heavier than 2025 and 2026 in most H1 months across the units - the navy line sits on top.</a:t>
+              <a:t>2027 runs heavier than 2025 and 2026 in most H1 months across the units - the orange (2027) bar stands tallest.</a:t>
             </a:r>
           </a:p>
         </p:txBody>

</xml_diff>

<commit_message>
Deck polish + forecast refresh: drop dashes, tighten bullets, redo Gantt, date+model
Text: removed dash separators across every slide and deck chart title/label
(colons/commas instead) and tightened the bullets to trader shorthand.

Timeline: rebuilt the ExxonMobil turnaround Gantt. Rows now carry the
refinery and unit, bars are class-colored with the kbd inside, a clean
month axis and legend, no truncated right-side text.

Model: as-of date moved to June 26th, 2026. Forecasting now folds the fresh
2026 H1 actuals into the unplanned baseline via a completeness-aware
seasonality (each calendar month averaged over the years that actually
reported it), so H1 gets the latest signal while H2 stays on the three
complete years (2023-2025); annual range bands use complete years only.
Default baseline window is now 2023-2026.

Co-Authored-By: Claude Opus 4.8 <noreply@anthropic.com>
Claude-Session: https://claude.ai/code/session_015p5NLGbwXS8USzMXyom8VW
</commit_message>
<xml_diff>
--- a/output/outage_deck.pptx
+++ b/output/outage_deck.pptx
@@ -9376,7 +9376,7 @@
                 </a:solidFill>
                 <a:latin typeface="Arial"/>
               </a:rPr>
-              <a:t>June 15th, 2026</a:t>
+              <a:t>June 26th, 2026</a:t>
             </a:r>
           </a:p>
         </p:txBody>
@@ -9636,7 +9636,7 @@
                 </a:solidFill>
                 <a:latin typeface="Arial"/>
               </a:rPr>
-              <a:t>Capacity offline by unit, region &amp; operator - and what it tightens</a:t>
+              <a:t>Capacity offline by unit, region &amp; operator, and what it tightens</a:t>
             </a:r>
           </a:p>
           <a:p>
@@ -9748,7 +9748,7 @@
                 </a:solidFill>
                 <a:latin typeface="Arial"/>
               </a:rPr>
-              <a:t>Total 2027 Outages by Unit - and What They Tighten</a:t>
+              <a:t>Total 2027 Outages by Unit, and What They Tighten</a:t>
             </a:r>
           </a:p>
         </p:txBody>
@@ -9986,7 +9986,7 @@
         <p:spPr>
           <a:xfrm>
             <a:off x="8887968" y="1783080"/>
-            <a:ext cx="3090672" cy="1042416"/>
+            <a:ext cx="3090672" cy="804672"/>
           </a:xfrm>
           <a:prstGeom prst="rect">
             <a:avLst/>
@@ -10011,7 +10011,7 @@
                 </a:solidFill>
                 <a:latin typeface="Arial"/>
               </a:rPr>
-              <a:t>Crude (CDU) down = the whole refinery's run is cut - every product from that site. FCC down = gasoline + octane. Reformer = octane. Hydrocracker = diesel / jet.</a:t>
+              <a:t>CDU down cuts the whole site's run, every product. FCC = gasoline + octane. Reformer = octane. Hydrocracker = diesel/jet.</a:t>
             </a:r>
           </a:p>
         </p:txBody>
@@ -10024,7 +10024,7 @@
         </p:nvSpPr>
         <p:spPr>
           <a:xfrm>
-            <a:off x="8686800" y="2663952"/>
+            <a:off x="8686800" y="2496312"/>
             <a:ext cx="82296" cy="82296"/>
           </a:xfrm>
           <a:prstGeom prst="rect">
@@ -10068,7 +10068,7 @@
         </p:nvSpPr>
         <p:spPr>
           <a:xfrm>
-            <a:off x="8887968" y="2599944"/>
+            <a:off x="8887968" y="2432304"/>
             <a:ext cx="3090672" cy="804672"/>
           </a:xfrm>
           <a:prstGeom prst="rect">
@@ -10094,7 +10094,7 @@
                 </a:solidFill>
                 <a:latin typeface="Arial"/>
               </a:rPr>
-              <a:t>Confirmed 2027 peak: CDU ~1,063, FCC ~492, hydrocracker ~219, reformer ~206 kbd - all in H1.</a:t>
+              <a:t>Confirmed peak (all H1): CDU ~1,063, FCC ~492, hydrocracker ~219, reformer ~206 kbd.</a:t>
             </a:r>
           </a:p>
         </p:txBody>
@@ -10107,7 +10107,7 @@
         </p:nvSpPr>
         <p:spPr>
           <a:xfrm>
-            <a:off x="8686800" y="3313176"/>
+            <a:off x="8686800" y="3145536"/>
             <a:ext cx="82296" cy="82296"/>
           </a:xfrm>
           <a:prstGeom prst="rect">
@@ -10151,8 +10151,8 @@
         </p:nvSpPr>
         <p:spPr>
           <a:xfrm>
-            <a:off x="8887968" y="3249168"/>
-            <a:ext cx="3090672" cy="804672"/>
+            <a:off x="8887968" y="3081528"/>
+            <a:ext cx="3090672" cy="566928"/>
           </a:xfrm>
           <a:prstGeom prst="rect">
             <a:avLst/>
@@ -10177,7 +10177,7 @@
                 </a:solidFill>
                 <a:latin typeface="Arial"/>
               </a:rPr>
-              <a:t>Read units separately, never added: a 250-kbd CDU plus a 100-kbd FCC is not '350 offline'.</a:t>
+              <a:t>Units read separately, never added: a 250 CDU plus a 100 FCC is not '350 offline'.</a:t>
             </a:r>
           </a:p>
         </p:txBody>
@@ -10190,7 +10190,7 @@
         </p:nvSpPr>
         <p:spPr>
           <a:xfrm>
-            <a:off x="8686800" y="3962400"/>
+            <a:off x="8686800" y="3627119"/>
             <a:ext cx="82296" cy="82296"/>
           </a:xfrm>
           <a:prstGeom prst="rect">
@@ -10234,8 +10234,8 @@
         </p:nvSpPr>
         <p:spPr>
           <a:xfrm>
-            <a:off x="8887968" y="3898392"/>
-            <a:ext cx="3090672" cy="1042416"/>
+            <a:off x="8887968" y="3563111"/>
+            <a:ext cx="3090672" cy="804672"/>
           </a:xfrm>
           <a:prstGeom prst="rect">
             <a:avLst/>
@@ -10260,7 +10260,7 @@
                 </a:solidFill>
                 <a:latin typeface="Arial"/>
               </a:rPr>
-              <a:t>Solid = confirmed (Exxon full-year + everyone's H1). Hatched = non-Exxon H2, still being booked - don't trade the autumn spike as real.</a:t>
+              <a:t>Solid = confirmed (Exxon full-year + everyone's H1). Hatched = non-Exxon H2: don't trade the autumn spike as real.</a:t>
             </a:r>
           </a:p>
         </p:txBody>
@@ -10299,7 +10299,7 @@
                 </a:solidFill>
                 <a:latin typeface="Arial"/>
               </a:rPr>
-              <a:t>Day-weighted concurrent capacity offline (a unit offline part of a month counts only for its days down), each unit once per month. Non-Exxon H2 2027 is a floor that fills in.</a:t>
+              <a:t>Day-weighted offline (a unit down part of a month counts only its days down), each unit once per month. Non-Exxon H2 2027 is a floor that fills in.</a:t>
             </a:r>
           </a:p>
         </p:txBody>
@@ -10356,7 +10356,7 @@
                 </a:solidFill>
                 <a:latin typeface="Arial"/>
               </a:rPr>
-              <a:t>What's Driving the Numbers - the Biggest Outages</a:t>
+              <a:t>What's Driving the Numbers: the Biggest Outages</a:t>
             </a:r>
           </a:p>
         </p:txBody>
@@ -10619,7 +10619,7 @@
                 </a:solidFill>
                 <a:latin typeface="Arial"/>
               </a:rPr>
-              <a:t>The big tonnage sits in PADD 3 - that's where one outage moves USGC supply and the export barrel most.</a:t>
+              <a:t>Big tonnage sits in PADD 3: that's where one outage moves USGC supply and the export barrel most.</a:t>
             </a:r>
           </a:p>
         </p:txBody>
@@ -10677,7 +10677,7 @@
         <p:spPr>
           <a:xfrm>
             <a:off x="8887968" y="2432304"/>
-            <a:ext cx="3090672" cy="1280160"/>
+            <a:ext cx="3090672" cy="1042416"/>
           </a:xfrm>
           <a:prstGeom prst="rect">
             <a:avLst/>
@@ -10702,7 +10702,7 @@
                 </a:solidFill>
                 <a:latin typeface="Arial"/>
               </a:rPr>
-              <a:t>Biggest single outages: Garyville (275 kbd), Cherry Point (250 kbd), Joliet (250 kbd) - mostly crude (CDU). One crude unit down cuts the whole site's run, every product.</a:t>
+              <a:t>Biggest: Garyville (275 kbd), Cherry Point (250 kbd), Joliet (250 kbd). Mostly crude (CDU); one CDU down cuts the whole site's run.</a:t>
             </a:r>
           </a:p>
         </p:txBody>
@@ -10715,7 +10715,7 @@
         </p:nvSpPr>
         <p:spPr>
           <a:xfrm>
-            <a:off x="8686800" y="3480816"/>
+            <a:off x="8686800" y="3313176"/>
             <a:ext cx="82296" cy="82296"/>
           </a:xfrm>
           <a:prstGeom prst="rect">
@@ -10759,7 +10759,7 @@
         </p:nvSpPr>
         <p:spPr>
           <a:xfrm>
-            <a:off x="8887968" y="3416808"/>
+            <a:off x="8887968" y="3249168"/>
             <a:ext cx="3090672" cy="804672"/>
           </a:xfrm>
           <a:prstGeom prst="rect">
@@ -10785,7 +10785,7 @@
                 </a:solidFill>
                 <a:latin typeface="Arial"/>
               </a:rPr>
-              <a:t>Read each bar alone - these are individual units, never added. The biggest single outage is ~275 kbd, not a summed total.</a:t>
+              <a:t>Read each bar alone: individual units, never added. Biggest single outage ~275 kbd, not a summed total.</a:t>
             </a:r>
           </a:p>
         </p:txBody>
@@ -10798,7 +10798,7 @@
         </p:nvSpPr>
         <p:spPr>
           <a:xfrm>
-            <a:off x="8686800" y="4130040"/>
+            <a:off x="8686800" y="3962400"/>
             <a:ext cx="82296" cy="82296"/>
           </a:xfrm>
           <a:prstGeom prst="rect">
@@ -10842,8 +10842,8 @@
         </p:nvSpPr>
         <p:spPr>
           <a:xfrm>
-            <a:off x="8887968" y="4066032"/>
-            <a:ext cx="3090672" cy="804672"/>
+            <a:off x="8887968" y="3898392"/>
+            <a:ext cx="3090672" cy="566928"/>
           </a:xfrm>
           <a:prstGeom prst="rect">
             <a:avLst/>
@@ -10868,7 +10868,7 @@
                 </a:solidFill>
                 <a:latin typeface="Arial"/>
               </a:rPr>
-              <a:t>Hatched bars are non-Exxon H2 - still being booked, so those autumn names are an indicative floor, not confirmed.</a:t>
+              <a:t>Hatched = non-Exxon H2: still being booked, an indicative floor, not confirmed.</a:t>
             </a:r>
           </a:p>
         </p:txBody>
@@ -10964,7 +10964,7 @@
                 </a:solidFill>
                 <a:latin typeface="Arial"/>
               </a:rPr>
-              <a:t>H1 Planned Outages per Unit &amp; Month - 2025 / 2026 / 2027</a:t>
+              <a:t>H1 Planned Outages per Unit &amp; Month: 2025 / 2026 / 2027</a:t>
             </a:r>
           </a:p>
         </p:txBody>
@@ -11003,7 +11003,7 @@
                 </a:solidFill>
                 <a:latin typeface="Arial"/>
               </a:rPr>
-              <a:t>Like-for-like Jan-Jun planned offline, broken out by unit and month (2027 confirmed through H1)</a:t>
+              <a:t>Like-for-like Jan-Jun planned offline, by unit and month (2027 confirmed through H1)</a:t>
             </a:r>
           </a:p>
         </p:txBody>
@@ -11227,7 +11227,7 @@
                 </a:solidFill>
                 <a:latin typeface="Arial"/>
               </a:rPr>
-              <a:t>H1 is the only honest cross-year read for 2027 - the book is confirmed through June; H2 is still being scheduled.</a:t>
+              <a:t>H1 is the only honest cross-year read: 2027 is booked through June; H2 is still being scheduled.</a:t>
             </a:r>
           </a:p>
         </p:txBody>
@@ -11310,7 +11310,7 @@
                 </a:solidFill>
                 <a:latin typeface="Arial"/>
               </a:rPr>
-              <a:t>2027 runs heavier than 2025 and 2026 in most H1 months across the units - the orange (2027) bar stands tallest.</a:t>
+              <a:t>2027 runs heavier than 2025 and 2026 in most H1 months: the orange bar stands tallest.</a:t>
             </a:r>
           </a:p>
         </p:txBody>
@@ -11393,7 +11393,7 @@
                 </a:solidFill>
                 <a:latin typeface="Arial"/>
               </a:rPr>
-              <a:t>Crude (CDU) H1 averages ~548 kbd vs ~325 (2026) / ~393 (2025), and crests in Mar (~1,063 kbd) - the spring turnaround peak.</a:t>
+              <a:t>Crude (CDU) averages ~548 kbd vs ~325 (2026), ~393 (2025); crests in Mar (~1,063 kbd).</a:t>
             </a:r>
           </a:p>
         </p:txBody>
@@ -11476,7 +11476,7 @@
                 </a:solidFill>
                 <a:latin typeface="Arial"/>
               </a:rPr>
-              <a:t>Read each unit and each month on its own, never added together - a heavier spring = tighter product supply.</a:t>
+              <a:t>Heavier spring = tighter product supply. Read each unit and month on its own, never added.</a:t>
             </a:r>
           </a:p>
         </p:txBody>
@@ -11515,7 +11515,7 @@
                 </a:solidFill>
                 <a:latin typeface="Arial"/>
               </a:rPr>
-              <a:t>Day-weighted capacity offline by month, planned only, each unit counted once per month. Per-panel y-axis. 2025/26 actuals; 2027 the booked plan.</a:t>
+              <a:t>Day-weighted capacity offline by month, planned only, each unit once per month. Per-panel y-axis. 2025/26 actuals; 2027 the booked plan.</a:t>
             </a:r>
           </a:p>
         </p:txBody>
@@ -11572,7 +11572,7 @@
                 </a:solidFill>
                 <a:latin typeface="Arial"/>
               </a:rPr>
-              <a:t>Outages by PADD by Unit - Where It Tightens</a:t>
+              <a:t>Outages by PADD by Unit: Where It Tightens</a:t>
             </a:r>
           </a:p>
         </p:txBody>
@@ -11859,7 +11859,7 @@
                 </a:solidFill>
                 <a:latin typeface="Arial"/>
               </a:rPr>
-              <a:t>PADD 3 (Gulf) is the swing region - most crude and FCC work lands there, tightening USGC supply and the export barrel.</a:t>
+              <a:t>PADD 3 (Gulf) is the swing region: most crude and FCC work lands there, tightening USGC supply and the export barrel.</a:t>
             </a:r>
           </a:p>
         </p:txBody>
@@ -11942,7 +11942,7 @@
                 </a:solidFill>
                 <a:latin typeface="Arial"/>
               </a:rPr>
-              <a:t>PADD 2 (Midwest) carries the spring crude (the Joliet event). PADD 5 (West) is islanded - a California outage doesn't get bailed out by other regions.</a:t>
+              <a:t>PADD 2 (Midwest) carries the spring crude (Joliet). PADD 5 (West) is islanded: a California outage isn't bailed out by other regions.</a:t>
             </a:r>
           </a:p>
         </p:txBody>
@@ -12000,7 +12000,7 @@
         <p:spPr>
           <a:xfrm>
             <a:off x="7653528" y="3172968"/>
-            <a:ext cx="4233672" cy="804672"/>
+            <a:ext cx="4233672" cy="566928"/>
           </a:xfrm>
           <a:prstGeom prst="rect">
             <a:avLst/>
@@ -12025,7 +12025,7 @@
                 </a:solidFill>
                 <a:latin typeface="Arial"/>
               </a:rPr>
-              <a:t>Timing: spring (Mar-May) and autumn (Sep-Oct) are the windows; summer is protected for driving-season gasoline.</a:t>
+              <a:t>Windows are spring (Mar-May) and autumn (Sep-Oct); summer is protected for driving-season gasoline.</a:t>
             </a:r>
           </a:p>
         </p:txBody>
@@ -12038,7 +12038,7 @@
         </p:nvSpPr>
         <p:spPr>
           <a:xfrm>
-            <a:off x="7452360" y="3931920"/>
+            <a:off x="7452360" y="3803904"/>
             <a:ext cx="82296" cy="82296"/>
           </a:xfrm>
           <a:prstGeom prst="rect">
@@ -12082,7 +12082,7 @@
         </p:nvSpPr>
         <p:spPr>
           <a:xfrm>
-            <a:off x="7653528" y="3867912"/>
+            <a:off x="7653528" y="3739896"/>
             <a:ext cx="4233672" cy="804672"/>
           </a:xfrm>
           <a:prstGeom prst="rect">
@@ -12108,7 +12108,7 @@
                 </a:solidFill>
                 <a:latin typeface="Arial"/>
               </a:rPr>
-              <a:t>Past the dotted line (H2) is non-Exxon-unconfirmed - those autumn bars are a floor and grow as operators book.</a:t>
+              <a:t>Past the dotted line (H2) is non-Exxon, unconfirmed: those autumn bars are a floor that grows as operators book.</a:t>
             </a:r>
           </a:p>
         </p:txBody>
@@ -12204,7 +12204,7 @@
                 </a:solidFill>
                 <a:latin typeface="Arial"/>
               </a:rPr>
-              <a:t>ExxonMobil 2027 - Per Unit</a:t>
+              <a:t>ExxonMobil 2027 by Unit</a:t>
             </a:r>
           </a:p>
         </p:txBody>
@@ -12342,8 +12342,8 @@
         </p:blipFill>
         <p:spPr>
           <a:xfrm>
-            <a:off x="365760" y="1827060"/>
-            <a:ext cx="8138160" cy="3569640"/>
+            <a:off x="365760" y="1403405"/>
+            <a:ext cx="8138160" cy="4416950"/>
           </a:xfrm>
           <a:prstGeom prst="rect">
             <a:avLst/>
@@ -12442,7 +12442,7 @@
         <p:spPr>
           <a:xfrm>
             <a:off x="8887968" y="1783080"/>
-            <a:ext cx="3090672" cy="1042416"/>
+            <a:ext cx="3090672" cy="804672"/>
           </a:xfrm>
           <a:prstGeom prst="rect">
             <a:avLst/>
@@ -12467,7 +12467,7 @@
                 </a:solidFill>
                 <a:latin typeface="Arial"/>
               </a:rPr>
-              <a:t>ExxonMobil is the only operator with a full-year 2027 plan - so it's the one refiner whose H2 we can confirm. Everyone else is H1-only.</a:t>
+              <a:t>ExxonMobil is the only operator with a full-year 2027 plan, so its H2 is the only confirmed H2. Everyone else is H1-only.</a:t>
             </a:r>
           </a:p>
         </p:txBody>
@@ -12480,7 +12480,7 @@
         </p:nvSpPr>
         <p:spPr>
           <a:xfrm>
-            <a:off x="8686800" y="2663952"/>
+            <a:off x="8686800" y="2496312"/>
             <a:ext cx="82296" cy="82296"/>
           </a:xfrm>
           <a:prstGeom prst="rect">
@@ -12524,7 +12524,7 @@
         </p:nvSpPr>
         <p:spPr>
           <a:xfrm>
-            <a:off x="8887968" y="2599944"/>
+            <a:off x="8887968" y="2432304"/>
             <a:ext cx="3090672" cy="1042416"/>
           </a:xfrm>
           <a:prstGeom prst="rect">
@@ -12550,7 +12550,7 @@
                 </a:solidFill>
                 <a:latin typeface="Arial"/>
               </a:rPr>
-              <a:t>Per unit, never summed - the 'Exxon ~700 kbd' figure was 8 Joliet units in one April turnaround added together; it's really ~250 kbd of crude.</a:t>
+              <a:t>Per unit, never summed: the 'Exxon ~700 kbd' figure was 8 Joliet units in one April turnaround added together. It's really ~250 kbd of crude.</a:t>
             </a:r>
           </a:p>
         </p:txBody>
@@ -12563,7 +12563,7 @@
         </p:nvSpPr>
         <p:spPr>
           <a:xfrm>
-            <a:off x="8686800" y="3480816"/>
+            <a:off x="8686800" y="3313176"/>
             <a:ext cx="82296" cy="82296"/>
           </a:xfrm>
           <a:prstGeom prst="rect">
@@ -12607,7 +12607,7 @@
         </p:nvSpPr>
         <p:spPr>
           <a:xfrm>
-            <a:off x="8887968" y="3416808"/>
+            <a:off x="8887968" y="3249168"/>
             <a:ext cx="3090672" cy="1042416"/>
           </a:xfrm>
           <a:prstGeom prst="rect">
@@ -12729,7 +12729,7 @@
                 </a:solidFill>
                 <a:latin typeface="Arial"/>
               </a:rPr>
-              <a:t>2027 Unplanned Scenario - the Risk on Top of Planned</a:t>
+              <a:t>2027 Unplanned Scenario: the Risk on Top of Planned</a:t>
             </a:r>
           </a:p>
         </p:txBody>
@@ -12768,7 +12768,7 @@
                 </a:solidFill>
                 <a:latin typeface="Arial"/>
               </a:rPr>
-              <a:t>Potential unplanned offline (kbd) modeled off the 2022-25 seasonal pattern</a:t>
+              <a:t>Potential unplanned offline (kbd) modeled on the 2023-26 seasonal pattern</a:t>
             </a:r>
           </a:p>
         </p:txBody>
@@ -13016,7 +13016,7 @@
                 </a:solidFill>
                 <a:latin typeface="Arial"/>
               </a:rPr>
-              <a:t>2027 has no actual unplanned yet - this is the risk range to carry on top of the booked planned slate.</a:t>
+              <a:t>2027 has no actual unplanned yet: this is the risk range on top of the booked plan.</a:t>
             </a:r>
           </a:p>
         </p:txBody>
@@ -13099,7 +13099,7 @@
                 </a:solidFill>
                 <a:latin typeface="Arial"/>
               </a:rPr>
-              <a:t>Average ~13,296 kbd unplanned; Conservative ~10,637 (calm year), Active ~17,285 (heavy). Booked planned is ~15,691 kbd.</a:t>
+              <a:t>Average ~13,046 kbd unplanned; Conservative ~10,437 (calm year), Active ~16,959 (heavy). Booked planned is ~15,691 kbd.</a:t>
             </a:r>
           </a:p>
         </p:txBody>
@@ -13182,7 +13182,7 @@
                 </a:solidFill>
                 <a:latin typeface="Arial"/>
               </a:rPr>
-              <a:t>Implied total ~26,328 / ~28,987 / ~32,976 kbd (Conservative / Average / Active).</a:t>
+              <a:t>Implied total ~26,127 / ~28,737 / ~32,650 kbd (Conservative / Average / Active).</a:t>
             </a:r>
           </a:p>
         </p:txBody>
@@ -13387,7 +13387,7 @@
                 </a:solidFill>
                 <a:latin typeface="Arial"/>
               </a:rPr>
-              <a:t>Scenario = mean 2022-25 monthly unplanned shape x {0.8 / 1.0 / 1.3}. A risk range, not a forecast; fully tunable in the Excel Scenario tab.</a:t>
+              <a:t>Scenario = mean 2023-26 monthly unplanned shape (completeness-aware) x {0.8 / 1.0 / 1.3}. A risk range, not a forecast.</a:t>
             </a:r>
           </a:p>
         </p:txBody>

</xml_diff>

<commit_message>
Decks: add relative-% charts (H1 cross-year, rest-of-26, tied vs standalone)
Both decks get a Relatives slide leading with percent/relative reads
instead of absolute kbd:
- relatives_by_unit: H1 planned offline % change by unit, 2027 vs the prior
  two years (cat +66% vs 26 / +24% vs 25; reformer +38% / -37%).
- relatives_forward_units: rest-of-2026 (H2 vs prior) and 2027 H1 (vs prior)
  by unit -- the reformer steps -11% -> +38%.
- tied_standalone_bars: 100%-stacked share tied to a crude TA vs standalone
  by unit (reformer 64% tied, hydrocracker 25%).

Main deck slide 6 (after H1), chem-feed slide 3 (after the forward book);
both 2-up, side-by-side, no overlap. Render-verified.

Script: reformer rest-of-2026 -14% -> -11% (consistent H2 basis, matches
the model and the new chart).

Co-Authored-By: Claude Opus 4.8 <noreply@anthropic.com>
Claude-Session: https://claude.ai/code/session_015p5NLGbwXS8USzMXyom8VW
</commit_message>
<xml_diff>
--- a/output/outage_deck.pptx
+++ b/output/outage_deck.pptx
@@ -15,6 +15,7 @@
     <p:sldId id="263" r:id="rId14"/>
     <p:sldId id="264" r:id="rId15"/>
     <p:sldId id="265" r:id="rId16"/>
+    <p:sldId id="266" r:id="rId17"/>
   </p:sldIdLst>
   <p:sldSz cx="12191695" cy="6858000" type="screen4x3"/>
   <p:notesSz cx="6858000" cy="9144000"/>
@@ -3591,7 +3592,7 @@
                 </a:solidFill>
                 <a:latin typeface="Arial"/>
               </a:rPr>
-              <a:t>What It Means for the Market: Gasoline &amp; Distillate</a:t>
+              <a:t>2027 Unplanned Scenario: the Risk on Top of Planned</a:t>
             </a:r>
           </a:p>
         </p:txBody>
@@ -3630,7 +3631,7 @@
                 </a:solidFill>
                 <a:latin typeface="Arial"/>
               </a:rPr>
-              <a:t>Spring crude turnarounds tighten both pools -- summer gasoline and a thin distillate cushion</a:t>
+              <a:t>Potential unplanned offline (kbd per month) modeled on the 2023-26 seasonal pattern</a:t>
             </a:r>
           </a:p>
         </p:txBody>
@@ -3709,6 +3710,243 @@
                 <a:latin typeface="Arial"/>
               </a:rPr>
               <a:t>9</a:t>
+            </a:r>
+          </a:p>
+        </p:txBody>
+      </p:sp>
+      <p:pic>
+        <p:nvPicPr>
+          <p:cNvPr id="6" name="Picture 5" descr="fan.png"/>
+          <p:cNvPicPr>
+            <a:picLocks noChangeAspect="1"/>
+          </p:cNvPicPr>
+          <p:nvPr/>
+        </p:nvPicPr>
+        <p:blipFill>
+          <a:blip r:embed="rId2"/>
+          <a:stretch>
+            <a:fillRect/>
+          </a:stretch>
+        </p:blipFill>
+        <p:spPr>
+          <a:xfrm>
+            <a:off x="1136504" y="1188720"/>
+            <a:ext cx="9888511" cy="4572000"/>
+          </a:xfrm>
+          <a:prstGeom prst="rect">
+            <a:avLst/>
+          </a:prstGeom>
+        </p:spPr>
+      </p:pic>
+      <p:sp>
+        <p:nvSpPr>
+          <p:cNvPr id="7" name="TextBox 6"/>
+          <p:cNvSpPr txBox="1"/>
+          <p:nvPr/>
+        </p:nvSpPr>
+        <p:spPr>
+          <a:xfrm>
+            <a:off x="457200" y="5888736"/>
+            <a:ext cx="11247120" cy="566928"/>
+          </a:xfrm>
+          <a:prstGeom prst="rect">
+            <a:avLst/>
+          </a:prstGeom>
+          <a:noFill/>
+        </p:spPr>
+        <p:txBody>
+          <a:bodyPr wrap="square" anchor="t" lIns="12700" rIns="12700" tIns="12700" bIns="12700">
+            <a:spAutoFit/>
+          </a:bodyPr>
+          <a:lstStyle/>
+          <a:p>
+            <a:pPr algn="l">
+              <a:spcAft>
+                <a:spcPts val="300"/>
+              </a:spcAft>
+            </a:pPr>
+            <a:r>
+              <a:rPr sz="800" b="0" i="1">
+                <a:solidFill>
+                  <a:srgbClr val="595959"/>
+                </a:solidFill>
+                <a:latin typeface="Arial"/>
+              </a:rPr>
+              <a:t>Scenario = mean 2023-26 monthly unplanned shape (completeness-aware) x {0.8 / 1.0 / 1.3}. Monthly concurrent offline, a risk range, not a forecast. Not an annual sum.</a:t>
+            </a:r>
+          </a:p>
+        </p:txBody>
+      </p:sp>
+    </p:spTree>
+  </p:cSld>
+  <p:clrMapOvr>
+    <a:masterClrMapping/>
+  </p:clrMapOvr>
+</p:sld>
+</file>
+
+<file path=ppt/slides/slide11.xml><?xml version="1.0" encoding="utf-8"?>
+<p:sld xmlns:a="http://schemas.openxmlformats.org/drawingml/2006/main" xmlns:p="http://schemas.openxmlformats.org/presentationml/2006/main" xmlns:r="http://schemas.openxmlformats.org/officeDocument/2006/relationships">
+  <p:cSld>
+    <p:spTree>
+      <p:nvGrpSpPr>
+        <p:cNvPr id="1" name=""/>
+        <p:cNvGrpSpPr/>
+        <p:nvPr/>
+      </p:nvGrpSpPr>
+      <p:grpSpPr/>
+      <p:sp>
+        <p:nvSpPr>
+          <p:cNvPr id="2" name="TextBox 1"/>
+          <p:cNvSpPr txBox="1"/>
+          <p:nvPr/>
+        </p:nvSpPr>
+        <p:spPr>
+          <a:xfrm>
+            <a:off x="411480" y="164592"/>
+            <a:ext cx="11338560" cy="640080"/>
+          </a:xfrm>
+          <a:prstGeom prst="rect">
+            <a:avLst/>
+          </a:prstGeom>
+          <a:noFill/>
+        </p:spPr>
+        <p:txBody>
+          <a:bodyPr wrap="square" anchor="ctr" lIns="12700" rIns="12700" tIns="12700" bIns="12700">
+            <a:spAutoFit/>
+          </a:bodyPr>
+          <a:lstStyle/>
+          <a:p>
+            <a:pPr algn="l">
+              <a:spcAft>
+                <a:spcPts val="300"/>
+              </a:spcAft>
+            </a:pPr>
+            <a:r>
+              <a:rPr sz="3000" b="0" i="0">
+                <a:solidFill>
+                  <a:srgbClr val="C00000"/>
+                </a:solidFill>
+                <a:latin typeface="Arial"/>
+              </a:rPr>
+              <a:t>What It Means for the Market: Gasoline &amp; Distillate</a:t>
+            </a:r>
+          </a:p>
+        </p:txBody>
+      </p:sp>
+      <p:sp>
+        <p:nvSpPr>
+          <p:cNvPr id="3" name="TextBox 2"/>
+          <p:cNvSpPr txBox="1"/>
+          <p:nvPr/>
+        </p:nvSpPr>
+        <p:spPr>
+          <a:xfrm>
+            <a:off x="457200" y="841248"/>
+            <a:ext cx="11247120" cy="274320"/>
+          </a:xfrm>
+          <a:prstGeom prst="rect">
+            <a:avLst/>
+          </a:prstGeom>
+          <a:noFill/>
+        </p:spPr>
+        <p:txBody>
+          <a:bodyPr wrap="square" anchor="t" lIns="12700" rIns="12700" tIns="12700" bIns="12700">
+            <a:spAutoFit/>
+          </a:bodyPr>
+          <a:lstStyle/>
+          <a:p>
+            <a:pPr algn="l">
+              <a:spcAft>
+                <a:spcPts val="300"/>
+              </a:spcAft>
+            </a:pPr>
+            <a:r>
+              <a:rPr sz="1200" b="0" i="0">
+                <a:solidFill>
+                  <a:srgbClr val="595959"/>
+                </a:solidFill>
+                <a:latin typeface="Arial"/>
+              </a:rPr>
+              <a:t>Spring crude turnarounds tighten both pools -- summer gasoline and a thin distillate cushion</a:t>
+            </a:r>
+          </a:p>
+        </p:txBody>
+      </p:sp>
+      <p:sp>
+        <p:nvSpPr>
+          <p:cNvPr id="4" name="TextBox 3"/>
+          <p:cNvSpPr txBox="1"/>
+          <p:nvPr/>
+        </p:nvSpPr>
+        <p:spPr>
+          <a:xfrm>
+            <a:off x="411480" y="6537960"/>
+            <a:ext cx="2743200" cy="292608"/>
+          </a:xfrm>
+          <a:prstGeom prst="rect">
+            <a:avLst/>
+          </a:prstGeom>
+          <a:noFill/>
+        </p:spPr>
+        <p:txBody>
+          <a:bodyPr wrap="square" anchor="ctr" lIns="12700" rIns="12700" tIns="12700" bIns="12700">
+            <a:spAutoFit/>
+          </a:bodyPr>
+          <a:lstStyle/>
+          <a:p>
+            <a:pPr algn="l">
+              <a:spcAft>
+                <a:spcPts val="300"/>
+              </a:spcAft>
+            </a:pPr>
+            <a:r>
+              <a:rPr sz="1300" b="1" i="0">
+                <a:solidFill>
+                  <a:srgbClr val="C00000"/>
+                </a:solidFill>
+                <a:latin typeface="Arial"/>
+              </a:rPr>
+              <a:t>Products Trading</a:t>
+            </a:r>
+          </a:p>
+        </p:txBody>
+      </p:sp>
+      <p:sp>
+        <p:nvSpPr>
+          <p:cNvPr id="5" name="TextBox 4"/>
+          <p:cNvSpPr txBox="1"/>
+          <p:nvPr/>
+        </p:nvSpPr>
+        <p:spPr>
+          <a:xfrm>
+            <a:off x="11430000" y="6547104"/>
+            <a:ext cx="640080" cy="274320"/>
+          </a:xfrm>
+          <a:prstGeom prst="rect">
+            <a:avLst/>
+          </a:prstGeom>
+          <a:noFill/>
+        </p:spPr>
+        <p:txBody>
+          <a:bodyPr wrap="square" anchor="t" lIns="12700" rIns="12700" tIns="12700" bIns="12700">
+            <a:spAutoFit/>
+          </a:bodyPr>
+          <a:lstStyle/>
+          <a:p>
+            <a:pPr algn="r">
+              <a:spcAft>
+                <a:spcPts val="300"/>
+              </a:spcAft>
+            </a:pPr>
+            <a:r>
+              <a:rPr sz="900" b="0" i="0">
+                <a:solidFill>
+                  <a:srgbClr val="595959"/>
+                </a:solidFill>
+                <a:latin typeface="Arial"/>
+              </a:rPr>
+              <a:t>10</a:t>
             </a:r>
           </a:p>
         </p:txBody>
@@ -4776,7 +5014,7 @@
                 </a:solidFill>
                 <a:latin typeface="Arial"/>
               </a:rPr>
-              <a:t>Gasoline Complex: Crude (CDU) + Cat Cracker (FCC) by PADD</a:t>
+              <a:t>Relatives: 2027 vs Prior Years, and Tied vs Standalone</a:t>
             </a:r>
           </a:p>
         </p:txBody>
@@ -4815,7 +5053,7 @@
                 </a:solidFill>
                 <a:latin typeface="Arial"/>
               </a:rPr>
-              <a:t>2027 crude (CDU, left) and cat-cracker (FCC, right) offline by region &amp; month -- the gasoline read</a:t>
+              <a:t>H1 planned offline % change by unit (left); share of downstream offline tied to a crude turnaround vs standalone (right)</a:t>
             </a:r>
           </a:p>
         </p:txBody>
@@ -4900,7 +5138,7 @@
       </p:sp>
       <p:pic>
         <p:nvPicPr>
-          <p:cNvPr id="6" name="Picture 5" descr="cdu_padd_27.png"/>
+          <p:cNvPr id="6" name="Picture 5" descr="relatives_units.png"/>
           <p:cNvPicPr>
             <a:picLocks noChangeAspect="1"/>
           </p:cNvPicPr>
@@ -4914,8 +5152,8 @@
         </p:blipFill>
         <p:spPr>
           <a:xfrm>
-            <a:off x="365760" y="1987757"/>
-            <a:ext cx="5632704" cy="3065365"/>
+            <a:off x="365760" y="2190575"/>
+            <a:ext cx="5632704" cy="2659730"/>
           </a:xfrm>
           <a:prstGeom prst="rect">
             <a:avLst/>
@@ -4924,7 +5162,7 @@
       </p:pic>
       <p:pic>
         <p:nvPicPr>
-          <p:cNvPr id="7" name="Picture 6" descr="fcc_padd_27.png"/>
+          <p:cNvPr id="7" name="Picture 6" descr="tied_standalone.png"/>
           <p:cNvPicPr>
             <a:picLocks noChangeAspect="1"/>
           </p:cNvPicPr>
@@ -4938,8 +5176,8 @@
         </p:blipFill>
         <p:spPr>
           <a:xfrm>
-            <a:off x="6190488" y="1985654"/>
-            <a:ext cx="5632704" cy="3069572"/>
+            <a:off x="6190488" y="2429490"/>
+            <a:ext cx="5632704" cy="2181899"/>
           </a:xfrm>
           <a:prstGeom prst="rect">
             <a:avLst/>
@@ -4980,7 +5218,7 @@
                 </a:solidFill>
                 <a:latin typeface="Arial"/>
               </a:rPr>
-              <a:t>Day-weighted concurrent offline by month, stacked by PADD. The FCC makes cat gasoline; a CDU outage cuts the whole barrel, gasoline included. P3 (Gulf) is the swing region; P2 (Midwest) carries the spring crude; P5 (West) is islanded. Past the dotted line = non-Exxon H2 (a floor that grows as operators book).</a:t>
+              <a:t>Left: H1 like-for-like, 2027 vs the prior two years -- the cat cracker leads (+66% vs 2026), the reformer beats last year but trails 2025. Right: standalone = the unit is down while crude keeps running (the cleaner product signal); the reformer is mostly tied to crude TAs, the hydrocracker mostly standalone.</a:t>
             </a:r>
           </a:p>
         </p:txBody>
@@ -5037,7 +5275,7 @@
                 </a:solidFill>
                 <a:latin typeface="Arial"/>
               </a:rPr>
-              <a:t>Distillate Complex: Crude (CDU) + Hydrocracker by PADD</a:t>
+              <a:t>Gasoline Complex: Crude (CDU) + Cat Cracker (FCC) by PADD</a:t>
             </a:r>
           </a:p>
         </p:txBody>
@@ -5076,7 +5314,7 @@
                 </a:solidFill>
                 <a:latin typeface="Arial"/>
               </a:rPr>
-              <a:t>2027 crude (CDU, left) and hydrocracker (right) offline by region &amp; month -- the diesel/jet read</a:t>
+              <a:t>2027 crude (CDU, left) and cat-cracker (FCC, right) offline by region &amp; month -- the gasoline read</a:t>
             </a:r>
           </a:p>
         </p:txBody>
@@ -5185,7 +5423,7 @@
       </p:pic>
       <p:pic>
         <p:nvPicPr>
-          <p:cNvPr id="7" name="Picture 6" descr="hcu_padd_27.png"/>
+          <p:cNvPr id="7" name="Picture 6" descr="fcc_padd_27.png"/>
           <p:cNvPicPr>
             <a:picLocks noChangeAspect="1"/>
           </p:cNvPicPr>
@@ -5241,7 +5479,7 @@
                 </a:solidFill>
                 <a:latin typeface="Arial"/>
               </a:rPr>
-              <a:t>Day-weighted concurrent offline by month, stacked by PADD. The hydrocracker makes diesel and jet; the same CDU outage that cuts gasoline cuts distillate too (the whole barrel is down). P3 (Gulf) and P2 (Midwest) carry the hydrocracker work. Past the dotted line = non-Exxon H2 (indicative).</a:t>
+              <a:t>Day-weighted concurrent offline by month, stacked by PADD. The FCC makes cat gasoline; a CDU outage cuts the whole barrel, gasoline included. P3 (Gulf) is the swing region; P2 (Midwest) carries the spring crude; P5 (West) is islanded. Past the dotted line = non-Exxon H2 (a floor that grows as operators book).</a:t>
             </a:r>
           </a:p>
         </p:txBody>
@@ -5298,7 +5536,7 @@
                 </a:solidFill>
                 <a:latin typeface="Arial"/>
               </a:rPr>
-              <a:t>Unplanned Offline: 2024-2026 Context</a:t>
+              <a:t>Distillate Complex: Crude (CDU) + Hydrocracker by PADD</a:t>
             </a:r>
           </a:p>
         </p:txBody>
@@ -5337,7 +5575,7 @@
                 </a:solidFill>
                 <a:latin typeface="Arial"/>
               </a:rPr>
-              <a:t>What unplanned actually looked like in recent years, to ground the 2027 scenario</a:t>
+              <a:t>2027 crude (CDU, left) and hydrocracker (right) offline by region &amp; month -- the diesel/jet read</a:t>
             </a:r>
           </a:p>
         </p:txBody>
@@ -5422,7 +5660,7 @@
       </p:sp>
       <p:pic>
         <p:nvPicPr>
-          <p:cNvPr id="6" name="Picture 5" descr="unplanned_context.png"/>
+          <p:cNvPr id="6" name="Picture 5" descr="cdu_padd_27.png"/>
           <p:cNvPicPr>
             <a:picLocks noChangeAspect="1"/>
           </p:cNvPicPr>
@@ -5436,17 +5674,41 @@
         </p:blipFill>
         <p:spPr>
           <a:xfrm>
-            <a:off x="1311891" y="1188720"/>
-            <a:ext cx="9537738" cy="4572000"/>
+            <a:off x="365760" y="1987757"/>
+            <a:ext cx="5632704" cy="3065365"/>
           </a:xfrm>
           <a:prstGeom prst="rect">
             <a:avLst/>
           </a:prstGeom>
         </p:spPr>
       </p:pic>
-      <p:sp>
-        <p:nvSpPr>
-          <p:cNvPr id="7" name="TextBox 6"/>
+      <p:pic>
+        <p:nvPicPr>
+          <p:cNvPr id="7" name="Picture 6" descr="hcu_padd_27.png"/>
+          <p:cNvPicPr>
+            <a:picLocks noChangeAspect="1"/>
+          </p:cNvPicPr>
+          <p:nvPr/>
+        </p:nvPicPr>
+        <p:blipFill>
+          <a:blip r:embed="rId3"/>
+          <a:stretch>
+            <a:fillRect/>
+          </a:stretch>
+        </p:blipFill>
+        <p:spPr>
+          <a:xfrm>
+            <a:off x="6190488" y="1985654"/>
+            <a:ext cx="5632704" cy="3069572"/>
+          </a:xfrm>
+          <a:prstGeom prst="rect">
+            <a:avLst/>
+          </a:prstGeom>
+        </p:spPr>
+      </p:pic>
+      <p:sp>
+        <p:nvSpPr>
+          <p:cNvPr id="8" name="TextBox 7"/>
           <p:cNvSpPr txBox="1"/>
           <p:nvPr/>
         </p:nvSpPr>
@@ -5478,7 +5740,7 @@
                 </a:solidFill>
                 <a:latin typeface="Arial"/>
               </a:rPr>
-              <a:t>Actual unplanned capacity offline by month, day-weighted. 2026 reported through June.</a:t>
+              <a:t>Day-weighted concurrent offline by month, stacked by PADD. The hydrocracker makes diesel and jet; the same CDU outage that cuts gasoline cuts distillate too (the whole barrel is down). P3 (Gulf) and P2 (Midwest) carry the hydrocracker work. Past the dotted line = non-Exxon H2 (indicative).</a:t>
             </a:r>
           </a:p>
         </p:txBody>
@@ -5535,7 +5797,7 @@
                 </a:solidFill>
                 <a:latin typeface="Arial"/>
               </a:rPr>
-              <a:t>2027 Unplanned Scenario: the Risk on Top of Planned</a:t>
+              <a:t>Unplanned Offline: 2024-2026 Context</a:t>
             </a:r>
           </a:p>
         </p:txBody>
@@ -5574,7 +5836,7 @@
                 </a:solidFill>
                 <a:latin typeface="Arial"/>
               </a:rPr>
-              <a:t>Potential unplanned offline (kbd per month) modeled on the 2023-26 seasonal pattern</a:t>
+              <a:t>What unplanned actually looked like in recent years, to ground the 2027 scenario</a:t>
             </a:r>
           </a:p>
         </p:txBody>
@@ -5659,7 +5921,7 @@
       </p:sp>
       <p:pic>
         <p:nvPicPr>
-          <p:cNvPr id="6" name="Picture 5" descr="fan.png"/>
+          <p:cNvPr id="6" name="Picture 5" descr="unplanned_context.png"/>
           <p:cNvPicPr>
             <a:picLocks noChangeAspect="1"/>
           </p:cNvPicPr>
@@ -5673,8 +5935,8 @@
         </p:blipFill>
         <p:spPr>
           <a:xfrm>
-            <a:off x="1136504" y="1188720"/>
-            <a:ext cx="9888511" cy="4572000"/>
+            <a:off x="1311891" y="1188720"/>
+            <a:ext cx="9537738" cy="4572000"/>
           </a:xfrm>
           <a:prstGeom prst="rect">
             <a:avLst/>
@@ -5715,7 +5977,7 @@
                 </a:solidFill>
                 <a:latin typeface="Arial"/>
               </a:rPr>
-              <a:t>Scenario = mean 2023-26 monthly unplanned shape (completeness-aware) x {0.8 / 1.0 / 1.3}. Monthly concurrent offline, a risk range, not a forecast. Not an annual sum.</a:t>
+              <a:t>Actual unplanned capacity offline by month, day-weighted. 2026 reported through June.</a:t>
             </a:r>
           </a:p>
         </p:txBody>

</xml_diff>